<commit_message>
Remove speaker notes from public slides
</commit_message>
<xml_diff>
--- a/slides/docker-session1-basics-setup.pptx
+++ b/slides/docker-session1-basics-setup.pptx
@@ -2,39 +2,36 @@
 <file path=ppt/presentation.xml><?xml version="1.0" encoding="utf-8"?>
 <p:presentation xmlns:p="http://schemas.openxmlformats.org/presentationml/2006/main">
   <p:sldMasterIdLst>
-    <p:sldMasterId xmlns:r="http://schemas.openxmlformats.org/officeDocument/2006/relationships" id="2147483648" r:id="R71682037539842c1"/>
+    <p:sldMasterId xmlns:r="http://schemas.openxmlformats.org/officeDocument/2006/relationships" id="2147483648" r:id="R43e294b9c21b4e9b"/>
   </p:sldMasterIdLst>
-  <p:notesMasterIdLst>
-    <p:notesMasterId xmlns:r="http://schemas.openxmlformats.org/officeDocument/2006/relationships" r:id="R94a4c5b484bb49ed"/>
-  </p:notesMasterIdLst>
   <p:sldIdLst>
-    <p:sldId xmlns:r="http://schemas.openxmlformats.org/officeDocument/2006/relationships" id="256" r:id="Rf69da4c77aa14877"/>
-    <p:sldId xmlns:r="http://schemas.openxmlformats.org/officeDocument/2006/relationships" id="257" r:id="Ra62d737291a341f8"/>
-    <p:sldId xmlns:r="http://schemas.openxmlformats.org/officeDocument/2006/relationships" id="258" r:id="R64fcee04469d4b34"/>
-    <p:sldId xmlns:r="http://schemas.openxmlformats.org/officeDocument/2006/relationships" id="259" r:id="R8afb3298b4c34037"/>
-    <p:sldId xmlns:r="http://schemas.openxmlformats.org/officeDocument/2006/relationships" id="260" r:id="R3e81faa42b1f45a9"/>
-    <p:sldId xmlns:r="http://schemas.openxmlformats.org/officeDocument/2006/relationships" id="261" r:id="R16b1c99a102a4e2c"/>
-    <p:sldId xmlns:r="http://schemas.openxmlformats.org/officeDocument/2006/relationships" id="262" r:id="R8443818646e1418a"/>
-    <p:sldId xmlns:r="http://schemas.openxmlformats.org/officeDocument/2006/relationships" id="263" r:id="Rfe4d8626476b4b89"/>
-    <p:sldId xmlns:r="http://schemas.openxmlformats.org/officeDocument/2006/relationships" id="264" r:id="R38d571769b8b4fb7"/>
-    <p:sldId xmlns:r="http://schemas.openxmlformats.org/officeDocument/2006/relationships" id="265" r:id="R2be77daeb5794d29"/>
-    <p:sldId xmlns:r="http://schemas.openxmlformats.org/officeDocument/2006/relationships" id="266" r:id="R4592594911174db7"/>
-    <p:sldId xmlns:r="http://schemas.openxmlformats.org/officeDocument/2006/relationships" id="267" r:id="Rbfc1196c73d14fee"/>
-    <p:sldId xmlns:r="http://schemas.openxmlformats.org/officeDocument/2006/relationships" id="268" r:id="R3bd45e89ae0840a3"/>
-    <p:sldId xmlns:r="http://schemas.openxmlformats.org/officeDocument/2006/relationships" id="269" r:id="Rcbc4603c5fcc418d"/>
-    <p:sldId xmlns:r="http://schemas.openxmlformats.org/officeDocument/2006/relationships" id="270" r:id="R7ead831eb8d4479b"/>
-    <p:sldId xmlns:r="http://schemas.openxmlformats.org/officeDocument/2006/relationships" id="271" r:id="R1e890ab4f2f34fea"/>
-    <p:sldId xmlns:r="http://schemas.openxmlformats.org/officeDocument/2006/relationships" id="272" r:id="Ra404254c708f46fc"/>
-    <p:sldId xmlns:r="http://schemas.openxmlformats.org/officeDocument/2006/relationships" id="273" r:id="R415a74d3aa4f42c1"/>
-    <p:sldId xmlns:r="http://schemas.openxmlformats.org/officeDocument/2006/relationships" id="274" r:id="Re4bc8bbeadd64223"/>
-    <p:sldId xmlns:r="http://schemas.openxmlformats.org/officeDocument/2006/relationships" id="275" r:id="R951e11affcac4112"/>
-    <p:sldId xmlns:r="http://schemas.openxmlformats.org/officeDocument/2006/relationships" id="276" r:id="R4524bbdd2be74179"/>
-    <p:sldId xmlns:r="http://schemas.openxmlformats.org/officeDocument/2006/relationships" id="277" r:id="R447b2860a5214d90"/>
-    <p:sldId xmlns:r="http://schemas.openxmlformats.org/officeDocument/2006/relationships" id="278" r:id="R423d82f930894519"/>
-    <p:sldId xmlns:r="http://schemas.openxmlformats.org/officeDocument/2006/relationships" id="279" r:id="R19c0e5820dfd4ecc"/>
-    <p:sldId xmlns:r="http://schemas.openxmlformats.org/officeDocument/2006/relationships" id="280" r:id="Ra9ff63b3e4234b63"/>
-    <p:sldId xmlns:r="http://schemas.openxmlformats.org/officeDocument/2006/relationships" id="281" r:id="R98d1d3b70bf74cff"/>
-    <p:sldId xmlns:r="http://schemas.openxmlformats.org/officeDocument/2006/relationships" id="282" r:id="Rf45c91722c264975"/>
+    <p:sldId xmlns:r="http://schemas.openxmlformats.org/officeDocument/2006/relationships" id="256" r:id="Rafb80402c4b64a15"/>
+    <p:sldId xmlns:r="http://schemas.openxmlformats.org/officeDocument/2006/relationships" id="257" r:id="R4ff45aacb81d4ff7"/>
+    <p:sldId xmlns:r="http://schemas.openxmlformats.org/officeDocument/2006/relationships" id="258" r:id="Rc55a6fa3ff404697"/>
+    <p:sldId xmlns:r="http://schemas.openxmlformats.org/officeDocument/2006/relationships" id="259" r:id="Reaf9421e1633459a"/>
+    <p:sldId xmlns:r="http://schemas.openxmlformats.org/officeDocument/2006/relationships" id="260" r:id="R78c477f96b4f48e5"/>
+    <p:sldId xmlns:r="http://schemas.openxmlformats.org/officeDocument/2006/relationships" id="261" r:id="R9ef852f5343b4d6d"/>
+    <p:sldId xmlns:r="http://schemas.openxmlformats.org/officeDocument/2006/relationships" id="262" r:id="R5905056220ce454a"/>
+    <p:sldId xmlns:r="http://schemas.openxmlformats.org/officeDocument/2006/relationships" id="263" r:id="R83c6540a0a0748b7"/>
+    <p:sldId xmlns:r="http://schemas.openxmlformats.org/officeDocument/2006/relationships" id="264" r:id="Rd003a8696a4648cf"/>
+    <p:sldId xmlns:r="http://schemas.openxmlformats.org/officeDocument/2006/relationships" id="265" r:id="R897320a0158f4872"/>
+    <p:sldId xmlns:r="http://schemas.openxmlformats.org/officeDocument/2006/relationships" id="266" r:id="R1bb31d5399c24aef"/>
+    <p:sldId xmlns:r="http://schemas.openxmlformats.org/officeDocument/2006/relationships" id="267" r:id="R16e547b4c3ea4e7c"/>
+    <p:sldId xmlns:r="http://schemas.openxmlformats.org/officeDocument/2006/relationships" id="268" r:id="Rd4a4d234627c4f1e"/>
+    <p:sldId xmlns:r="http://schemas.openxmlformats.org/officeDocument/2006/relationships" id="269" r:id="Rb02cb25556e44831"/>
+    <p:sldId xmlns:r="http://schemas.openxmlformats.org/officeDocument/2006/relationships" id="270" r:id="Rc2ae40f3cdb440b5"/>
+    <p:sldId xmlns:r="http://schemas.openxmlformats.org/officeDocument/2006/relationships" id="271" r:id="R74dde4a93c1044d0"/>
+    <p:sldId xmlns:r="http://schemas.openxmlformats.org/officeDocument/2006/relationships" id="272" r:id="R087ac154a8e14c2d"/>
+    <p:sldId xmlns:r="http://schemas.openxmlformats.org/officeDocument/2006/relationships" id="273" r:id="Rd2896612a69d4967"/>
+    <p:sldId xmlns:r="http://schemas.openxmlformats.org/officeDocument/2006/relationships" id="274" r:id="R099d9a79a18040cb"/>
+    <p:sldId xmlns:r="http://schemas.openxmlformats.org/officeDocument/2006/relationships" id="275" r:id="R631de70a9b524f2a"/>
+    <p:sldId xmlns:r="http://schemas.openxmlformats.org/officeDocument/2006/relationships" id="276" r:id="R76ea71f2b5e3436c"/>
+    <p:sldId xmlns:r="http://schemas.openxmlformats.org/officeDocument/2006/relationships" id="277" r:id="Re3ccc8fe3f194967"/>
+    <p:sldId xmlns:r="http://schemas.openxmlformats.org/officeDocument/2006/relationships" id="278" r:id="R997c7a3e7fe94727"/>
+    <p:sldId xmlns:r="http://schemas.openxmlformats.org/officeDocument/2006/relationships" id="279" r:id="R523e56ed19ca4939"/>
+    <p:sldId xmlns:r="http://schemas.openxmlformats.org/officeDocument/2006/relationships" id="280" r:id="R17667690b9224814"/>
+    <p:sldId xmlns:r="http://schemas.openxmlformats.org/officeDocument/2006/relationships" id="281" r:id="Ra5f29b033f154389"/>
+    <p:sldId xmlns:r="http://schemas.openxmlformats.org/officeDocument/2006/relationships" id="282" r:id="R43390519fc5949a8"/>
   </p:sldIdLst>
   <p:sldSz cx="12192000" cy="6858000"/>
   <p:notesSz cx="6858000" cy="9144000"/>
@@ -136,2283 +133,6 @@
 </p:presentation>
 </file>
 
-<file path=ppt/notesMasters/notesMaster1.xml><?xml version="1.0" encoding="utf-8"?>
-<p:notesMaster xmlns:p="http://schemas.openxmlformats.org/presentationml/2006/main">
-  <p:cSld>
-    <p:bg>
-      <p:bgRef idx="1001">
-        <a:schemeClr xmlns:a="http://schemas.openxmlformats.org/drawingml/2006/main" val="bg1"/>
-      </p:bgRef>
-    </p:bg>
-    <p:spTree>
-      <p:nvGrpSpPr>
-        <p:cNvPr id="1" name=""/>
-        <p:cNvGrpSpPr/>
-        <p:nvPr/>
-      </p:nvGrpSpPr>
-      <p:grpSpPr>
-        <a:xfrm xmlns:a="http://schemas.openxmlformats.org/drawingml/2006/main"/>
-      </p:grpSpPr>
-      <p:sp>
-        <p:nvSpPr>
-          <p:cNvPr id="2" name="Header Placeholder"/>
-          <p:cNvSpPr/>
-          <p:nvPr>
-            <p:ph type="hdr" sz="quarter"/>
-          </p:nvPr>
-        </p:nvSpPr>
-        <p:spPr>
-          <a:prstGeom xmlns:a="http://schemas.openxmlformats.org/drawingml/2006/main" prst="rect">
-            <a:avLst/>
-          </a:prstGeom>
-        </p:spPr>
-        <p:txBody>
-          <a:bodyPr xmlns:a="http://schemas.openxmlformats.org/drawingml/2006/main"/>
-          <a:lstStyle xmlns:a="http://schemas.openxmlformats.org/drawingml/2006/main"/>
-          <a:p xmlns:a="http://schemas.openxmlformats.org/drawingml/2006/main"/>
-        </p:txBody>
-      </p:sp>
-      <p:sp>
-        <p:nvSpPr>
-          <p:cNvPr id="3" name="Date Placeholder"/>
-          <p:cNvSpPr/>
-          <p:nvPr>
-            <p:ph type="dt" sz="quarter" idx="1"/>
-          </p:nvPr>
-        </p:nvSpPr>
-        <p:spPr>
-          <a:prstGeom xmlns:a="http://schemas.openxmlformats.org/drawingml/2006/main" prst="rect">
-            <a:avLst/>
-          </a:prstGeom>
-        </p:spPr>
-        <p:txBody>
-          <a:bodyPr xmlns:a="http://schemas.openxmlformats.org/drawingml/2006/main"/>
-          <a:lstStyle xmlns:a="http://schemas.openxmlformats.org/drawingml/2006/main"/>
-          <a:p xmlns:a="http://schemas.openxmlformats.org/drawingml/2006/main"/>
-        </p:txBody>
-      </p:sp>
-      <p:sp>
-        <p:nvSpPr>
-          <p:cNvPr id="4" name="Slide Image Placeholder"/>
-          <p:cNvSpPr/>
-          <p:nvPr>
-            <p:ph type="sldImg" idx="2"/>
-          </p:nvPr>
-        </p:nvSpPr>
-        <p:spPr>
-          <a:prstGeom xmlns:a="http://schemas.openxmlformats.org/drawingml/2006/main" prst="rect">
-            <a:avLst/>
-          </a:prstGeom>
-        </p:spPr>
-        <p:txBody>
-          <a:bodyPr xmlns:a="http://schemas.openxmlformats.org/drawingml/2006/main"/>
-          <a:lstStyle xmlns:a="http://schemas.openxmlformats.org/drawingml/2006/main"/>
-          <a:p xmlns:a="http://schemas.openxmlformats.org/drawingml/2006/main"/>
-        </p:txBody>
-      </p:sp>
-      <p:sp>
-        <p:nvSpPr>
-          <p:cNvPr id="5" name="Notes Placeholder"/>
-          <p:cNvSpPr/>
-          <p:nvPr>
-            <p:ph type="body" sz="quarter" idx="3"/>
-          </p:nvPr>
-        </p:nvSpPr>
-        <p:spPr>
-          <a:prstGeom xmlns:a="http://schemas.openxmlformats.org/drawingml/2006/main" prst="rect">
-            <a:avLst/>
-          </a:prstGeom>
-        </p:spPr>
-        <p:txBody>
-          <a:bodyPr xmlns:a="http://schemas.openxmlformats.org/drawingml/2006/main"/>
-          <a:lstStyle xmlns:a="http://schemas.openxmlformats.org/drawingml/2006/main"/>
-          <a:p xmlns:a="http://schemas.openxmlformats.org/drawingml/2006/main"/>
-        </p:txBody>
-      </p:sp>
-      <p:sp>
-        <p:nvSpPr>
-          <p:cNvPr id="6" name="Footer Placeholder"/>
-          <p:cNvSpPr/>
-          <p:nvPr>
-            <p:ph type="ftr" sz="quarter" idx="4"/>
-          </p:nvPr>
-        </p:nvSpPr>
-        <p:spPr>
-          <a:prstGeom xmlns:a="http://schemas.openxmlformats.org/drawingml/2006/main" prst="rect">
-            <a:avLst/>
-          </a:prstGeom>
-        </p:spPr>
-        <p:txBody>
-          <a:bodyPr xmlns:a="http://schemas.openxmlformats.org/drawingml/2006/main"/>
-          <a:lstStyle xmlns:a="http://schemas.openxmlformats.org/drawingml/2006/main"/>
-          <a:p xmlns:a="http://schemas.openxmlformats.org/drawingml/2006/main"/>
-        </p:txBody>
-      </p:sp>
-      <p:sp>
-        <p:nvSpPr>
-          <p:cNvPr id="7" name="Slide Number Placeholder"/>
-          <p:cNvSpPr/>
-          <p:nvPr>
-            <p:ph type="sldNum" sz="quarter" idx="5"/>
-          </p:nvPr>
-        </p:nvSpPr>
-        <p:spPr>
-          <a:prstGeom xmlns:a="http://schemas.openxmlformats.org/drawingml/2006/main" prst="rect">
-            <a:avLst/>
-          </a:prstGeom>
-        </p:spPr>
-        <p:txBody>
-          <a:bodyPr xmlns:a="http://schemas.openxmlformats.org/drawingml/2006/main"/>
-          <a:lstStyle xmlns:a="http://schemas.openxmlformats.org/drawingml/2006/main"/>
-          <a:p xmlns:a="http://schemas.openxmlformats.org/drawingml/2006/main"/>
-        </p:txBody>
-      </p:sp>
-    </p:spTree>
-  </p:cSld>
-  <p:clrMap bg1="lt1" tx1="dk1" bg2="lt2" tx2="dk2" accent1="accent1" accent2="accent2" accent3="accent3" accent4="accent4" accent5="accent5" accent6="accent6" hlink="hlink" folHlink="folHlink"/>
-  <p:notesStyle>
-    <a:lvl1pPr xmlns:a="http://schemas.openxmlformats.org/drawingml/2006/main" marL="0" algn="l" defTabSz="914400" rtl="0" eaLnBrk="1" latinLnBrk="0" hangingPunct="1">
-      <a:defRPr sz="1200" kern="1200"/>
-    </a:lvl1pPr>
-  </p:notesStyle>
-</p:notesMaster>
-</file>
-
-<file path=ppt/notesMasters/theme/theme3.xml><?xml version="1.0" encoding="utf-8"?>
-<a:theme xmlns:a="http://schemas.openxmlformats.org/drawingml/2006/main" name="ChatGPT">
-  <a:themeElements>
-    <a:clrScheme name="ChatGPT">
-      <a:dk1>
-        <a:srgbClr val="000000"/>
-      </a:dk1>
-      <a:lt1>
-        <a:srgbClr val="FFFFFF"/>
-      </a:lt1>
-      <a:dk2>
-        <a:srgbClr val="0E2841"/>
-      </a:dk2>
-      <a:lt2>
-        <a:srgbClr val="E8E8E8"/>
-      </a:lt2>
-      <a:accent1>
-        <a:srgbClr val="156082"/>
-      </a:accent1>
-      <a:accent2>
-        <a:srgbClr val="E97132"/>
-      </a:accent2>
-      <a:accent3>
-        <a:srgbClr val="196B24"/>
-      </a:accent3>
-      <a:accent4>
-        <a:srgbClr val="0F9ED5"/>
-      </a:accent4>
-      <a:accent5>
-        <a:srgbClr val="A02B93"/>
-      </a:accent5>
-      <a:accent6>
-        <a:srgbClr val="4EA72E"/>
-      </a:accent6>
-      <a:hlink>
-        <a:srgbClr val="467886"/>
-      </a:hlink>
-      <a:folHlink>
-        <a:srgbClr val="96607D"/>
-      </a:folHlink>
-    </a:clrScheme>
-    <a:fontScheme name="Office">
-      <a:majorFont>
-        <a:latin typeface="Calibri Light"/>
-        <a:ea typeface="Calibri Light"/>
-        <a:cs typeface="Calibri Light"/>
-      </a:majorFont>
-      <a:minorFont>
-        <a:latin typeface="Calibri"/>
-        <a:ea typeface="Calibri"/>
-        <a:cs typeface="Calibri"/>
-      </a:minorFont>
-    </a:fontScheme>
-    <a:fmtScheme name="ChatGPT">
-      <a:fillStyleLst>
-        <a:solidFill>
-          <a:schemeClr val="phClr"/>
-        </a:solidFill>
-        <a:gradFill>
-          <a:gsLst>
-            <a:gs pos="0">
-              <a:schemeClr val="phClr">
-                <a:tint val="67000"/>
-                <a:lumMod val="110000"/>
-                <a:satMod val="105000"/>
-              </a:schemeClr>
-            </a:gs>
-            <a:gs pos="50000">
-              <a:schemeClr val="phClr">
-                <a:tint val="73000"/>
-                <a:lumMod val="105000"/>
-                <a:satMod val="103000"/>
-              </a:schemeClr>
-            </a:gs>
-            <a:gs pos="100000">
-              <a:schemeClr val="phClr">
-                <a:tint val="81000"/>
-                <a:lumMod val="105000"/>
-                <a:satMod val="109000"/>
-              </a:schemeClr>
-            </a:gs>
-          </a:gsLst>
-          <a:lin ang="5400000" scaled="0"/>
-        </a:gradFill>
-        <a:gradFill>
-          <a:gsLst>
-            <a:gs pos="0">
-              <a:schemeClr val="phClr">
-                <a:tint val="94000"/>
-                <a:lumMod val="102000"/>
-                <a:satMod val="103000"/>
-              </a:schemeClr>
-            </a:gs>
-            <a:gs pos="50000">
-              <a:schemeClr val="phClr">
-                <a:shade val="100000"/>
-                <a:lumMod val="100000"/>
-                <a:satMod val="110000"/>
-              </a:schemeClr>
-            </a:gs>
-            <a:gs pos="100000">
-              <a:schemeClr val="phClr">
-                <a:shade val="78000"/>
-                <a:lumMod val="99000"/>
-                <a:satMod val="120000"/>
-              </a:schemeClr>
-            </a:gs>
-          </a:gsLst>
-          <a:lin ang="5400000" scaled="0"/>
-        </a:gradFill>
-      </a:fillStyleLst>
-      <a:lnStyleLst>
-        <a:ln w="12700">
-          <a:solidFill>
-            <a:schemeClr val="phClr"/>
-          </a:solidFill>
-          <a:prstDash val="solid"/>
-        </a:ln>
-        <a:ln w="19050">
-          <a:solidFill>
-            <a:schemeClr val="phClr"/>
-          </a:solidFill>
-          <a:prstDash val="solid"/>
-        </a:ln>
-        <a:ln w="25400">
-          <a:solidFill>
-            <a:schemeClr val="phClr"/>
-          </a:solidFill>
-          <a:prstDash val="solid"/>
-        </a:ln>
-      </a:lnStyleLst>
-      <a:effectStyleLst>
-        <a:effectStyle>
-          <a:effectLst/>
-        </a:effectStyle>
-        <a:effectStyle>
-          <a:effectLst/>
-        </a:effectStyle>
-        <a:effectStyle>
-          <a:effectLst>
-            <a:outerShdw blurRad="57150" dist="19050" dir="5400000">
-              <a:srgbClr val="000000">
-                <a:alpha val="16000"/>
-              </a:srgbClr>
-            </a:outerShdw>
-          </a:effectLst>
-        </a:effectStyle>
-        <a:effectStyle>
-          <a:effectLst>
-            <a:outerShdw blurRad="19050" dist="9525" dir="5400000">
-              <a:srgbClr val="000000">
-                <a:alpha val="6000"/>
-              </a:srgbClr>
-            </a:outerShdw>
-          </a:effectLst>
-        </a:effectStyle>
-        <a:effectStyle>
-          <a:effectLst>
-            <a:outerShdw blurRad="28575" dist="9525" dir="5400000">
-              <a:srgbClr val="000000">
-                <a:alpha val="8000"/>
-              </a:srgbClr>
-            </a:outerShdw>
-          </a:effectLst>
-        </a:effectStyle>
-        <a:effectStyle>
-          <a:effectLst>
-            <a:outerShdw blurRad="57150" dist="19050" dir="5400000">
-              <a:srgbClr val="000000">
-                <a:alpha val="10000"/>
-              </a:srgbClr>
-            </a:outerShdw>
-          </a:effectLst>
-        </a:effectStyle>
-        <a:effectStyle>
-          <a:effectLst>
-            <a:outerShdw blurRad="114300" dist="38100" dir="5400000">
-              <a:srgbClr val="000000">
-                <a:alpha val="12000"/>
-              </a:srgbClr>
-            </a:outerShdw>
-          </a:effectLst>
-        </a:effectStyle>
-        <a:effectStyle>
-          <a:effectLst>
-            <a:outerShdw blurRad="171450" dist="57150" dir="5400000">
-              <a:srgbClr val="000000">
-                <a:alpha val="16000"/>
-              </a:srgbClr>
-            </a:outerShdw>
-          </a:effectLst>
-        </a:effectStyle>
-        <a:effectStyle>
-          <a:effectLst>
-            <a:outerShdw blurRad="266700" dist="95250" dir="5400000">
-              <a:srgbClr val="000000">
-                <a:alpha val="24000"/>
-              </a:srgbClr>
-            </a:outerShdw>
-          </a:effectLst>
-        </a:effectStyle>
-      </a:effectStyleLst>
-      <a:bgFillStyleLst>
-        <a:solidFill>
-          <a:schemeClr val="phClr"/>
-        </a:solidFill>
-        <a:solidFill>
-          <a:schemeClr val="phClr">
-            <a:tint val="95000"/>
-            <a:satMod val="170000"/>
-          </a:schemeClr>
-        </a:solidFill>
-        <a:gradFill>
-          <a:gsLst>
-            <a:gs pos="0">
-              <a:schemeClr val="phClr">
-                <a:tint val="93000"/>
-                <a:shade val="98000"/>
-                <a:lumMod val="102000"/>
-                <a:satMod val="150000"/>
-              </a:schemeClr>
-            </a:gs>
-            <a:gs pos="50000">
-              <a:schemeClr val="phClr">
-                <a:tint val="98000"/>
-                <a:shade val="90000"/>
-                <a:lumMod val="103000"/>
-                <a:satMod val="130000"/>
-              </a:schemeClr>
-            </a:gs>
-            <a:gs pos="100000">
-              <a:schemeClr val="phClr">
-                <a:shade val="63000"/>
-                <a:satMod val="120000"/>
-              </a:schemeClr>
-            </a:gs>
-          </a:gsLst>
-          <a:lin ang="5400000" scaled="0"/>
-        </a:gradFill>
-      </a:bgFillStyleLst>
-    </a:fmtScheme>
-  </a:themeElements>
-</a:theme>
-</file>
-
-<file path=ppt/notesSlides/notesSlide1.xml><?xml version="1.0" encoding="utf-8"?>
-<p:notes xmlns:p="http://schemas.openxmlformats.org/presentationml/2006/main">
-  <p:cSld>
-    <p:spTree>
-      <p:nvGrpSpPr>
-        <p:cNvPr id="1" name=""/>
-        <p:cNvGrpSpPr/>
-        <p:nvPr/>
-      </p:nvGrpSpPr>
-      <p:grpSpPr>
-        <a:xfrm xmlns:a="http://schemas.openxmlformats.org/drawingml/2006/main"/>
-      </p:grpSpPr>
-      <p:sp>
-        <p:nvSpPr>
-          <p:cNvPr id="2" name="Slide Image Placeholder 1"/>
-          <p:cNvSpPr>
-            <a:spLocks xmlns:a="http://schemas.openxmlformats.org/drawingml/2006/main" noGrp="1"/>
-          </p:cNvSpPr>
-          <p:nvPr>
-            <p:ph type="sldImg" idx="0"/>
-          </p:nvPr>
-        </p:nvSpPr>
-        <p:spPr/>
-      </p:sp>
-      <p:sp>
-        <p:nvSpPr>
-          <p:cNvPr id="3" name="Notes Placeholder 2"/>
-          <p:cNvSpPr>
-            <a:spLocks xmlns:a="http://schemas.openxmlformats.org/drawingml/2006/main" noGrp="1"/>
-          </p:cNvSpPr>
-          <p:nvPr>
-            <p:ph type="body" idx="1"/>
-          </p:nvPr>
-        </p:nvSpPr>
-        <p:spPr/>
-        <p:txBody>
-          <a:bodyPr xmlns:a="http://schemas.openxmlformats.org/drawingml/2006/main"/>
-          <a:lstStyle xmlns:a="http://schemas.openxmlformats.org/drawingml/2006/main"/>
-          <a:p xmlns:a="http://schemas.openxmlformats.org/drawingml/2006/main">
-            <a:r>
-              <a:t>開場先建立課程目標：這堂不是要背指令，而是要理解容器為什麼存在，然後親手跑起第一個 Web 伺服器。</a:t>
-            </a:r>
-          </a:p>
-        </p:txBody>
-      </p:sp>
-      <p:sp>
-        <p:nvSpPr>
-          <p:cNvPr id="4" name="Slide Number Placeholder 3"/>
-          <p:cNvSpPr>
-            <a:spLocks xmlns:a="http://schemas.openxmlformats.org/drawingml/2006/main" noGrp="1"/>
-          </p:cNvSpPr>
-          <p:nvPr>
-            <p:ph type="sldNum" idx="5"/>
-          </p:nvPr>
-        </p:nvSpPr>
-        <p:spPr/>
-        <p:txBody>
-          <a:bodyPr xmlns:a="http://schemas.openxmlformats.org/drawingml/2006/main"/>
-          <a:lstStyle xmlns:a="http://schemas.openxmlformats.org/drawingml/2006/main"/>
-          <a:p xmlns:a="http://schemas.openxmlformats.org/drawingml/2006/main"/>
-        </p:txBody>
-      </p:sp>
-    </p:spTree>
-  </p:cSld>
-  <p:clrMapOvr>
-    <a:masterClrMapping xmlns:a="http://schemas.openxmlformats.org/drawingml/2006/main"/>
-  </p:clrMapOvr>
-</p:notes>
-</file>
-
-<file path=ppt/notesSlides/notesSlide10.xml><?xml version="1.0" encoding="utf-8"?>
-<p:notes xmlns:p="http://schemas.openxmlformats.org/presentationml/2006/main">
-  <p:cSld>
-    <p:spTree>
-      <p:nvGrpSpPr>
-        <p:cNvPr id="1" name=""/>
-        <p:cNvGrpSpPr/>
-        <p:nvPr/>
-      </p:nvGrpSpPr>
-      <p:grpSpPr>
-        <a:xfrm xmlns:a="http://schemas.openxmlformats.org/drawingml/2006/main"/>
-      </p:grpSpPr>
-      <p:sp>
-        <p:nvSpPr>
-          <p:cNvPr id="2" name="Slide Image Placeholder 1"/>
-          <p:cNvSpPr>
-            <a:spLocks xmlns:a="http://schemas.openxmlformats.org/drawingml/2006/main" noGrp="1"/>
-          </p:cNvSpPr>
-          <p:nvPr>
-            <p:ph type="sldImg" idx="0"/>
-          </p:nvPr>
-        </p:nvSpPr>
-        <p:spPr/>
-      </p:sp>
-      <p:sp>
-        <p:nvSpPr>
-          <p:cNvPr id="3" name="Notes Placeholder 2"/>
-          <p:cNvSpPr>
-            <a:spLocks xmlns:a="http://schemas.openxmlformats.org/drawingml/2006/main" noGrp="1"/>
-          </p:cNvSpPr>
-          <p:nvPr>
-            <p:ph type="body" idx="1"/>
-          </p:nvPr>
-        </p:nvSpPr>
-        <p:spPr/>
-        <p:txBody>
-          <a:bodyPr xmlns:a="http://schemas.openxmlformats.org/drawingml/2006/main"/>
-          <a:lstStyle xmlns:a="http://schemas.openxmlformats.org/drawingml/2006/main"/>
-          <a:p xmlns:a="http://schemas.openxmlformats.org/drawingml/2006/main">
-            <a:r>
-              <a:t>練習題來自 exercises.md 第 1 堂概念題 Q2 與 Q4。</a:t>
-            </a:r>
-          </a:p>
-        </p:txBody>
-      </p:sp>
-      <p:sp>
-        <p:nvSpPr>
-          <p:cNvPr id="4" name="Slide Number Placeholder 3"/>
-          <p:cNvSpPr>
-            <a:spLocks xmlns:a="http://schemas.openxmlformats.org/drawingml/2006/main" noGrp="1"/>
-          </p:cNvSpPr>
-          <p:nvPr>
-            <p:ph type="sldNum" idx="5"/>
-          </p:nvPr>
-        </p:nvSpPr>
-        <p:spPr/>
-        <p:txBody>
-          <a:bodyPr xmlns:a="http://schemas.openxmlformats.org/drawingml/2006/main"/>
-          <a:lstStyle xmlns:a="http://schemas.openxmlformats.org/drawingml/2006/main"/>
-          <a:p xmlns:a="http://schemas.openxmlformats.org/drawingml/2006/main"/>
-        </p:txBody>
-      </p:sp>
-    </p:spTree>
-  </p:cSld>
-  <p:clrMapOvr>
-    <a:masterClrMapping xmlns:a="http://schemas.openxmlformats.org/drawingml/2006/main"/>
-  </p:clrMapOvr>
-</p:notes>
-</file>
-
-<file path=ppt/notesSlides/notesSlide11.xml><?xml version="1.0" encoding="utf-8"?>
-<p:notes xmlns:p="http://schemas.openxmlformats.org/presentationml/2006/main">
-  <p:cSld>
-    <p:spTree>
-      <p:nvGrpSpPr>
-        <p:cNvPr id="1" name=""/>
-        <p:cNvGrpSpPr/>
-        <p:nvPr/>
-      </p:nvGrpSpPr>
-      <p:grpSpPr>
-        <a:xfrm xmlns:a="http://schemas.openxmlformats.org/drawingml/2006/main"/>
-      </p:grpSpPr>
-      <p:sp>
-        <p:nvSpPr>
-          <p:cNvPr id="2" name="Slide Image Placeholder 1"/>
-          <p:cNvSpPr>
-            <a:spLocks xmlns:a="http://schemas.openxmlformats.org/drawingml/2006/main" noGrp="1"/>
-          </p:cNvSpPr>
-          <p:nvPr>
-            <p:ph type="sldImg" idx="0"/>
-          </p:nvPr>
-        </p:nvSpPr>
-        <p:spPr/>
-      </p:sp>
-      <p:sp>
-        <p:nvSpPr>
-          <p:cNvPr id="3" name="Notes Placeholder 2"/>
-          <p:cNvSpPr>
-            <a:spLocks xmlns:a="http://schemas.openxmlformats.org/drawingml/2006/main" noGrp="1"/>
-          </p:cNvSpPr>
-          <p:nvPr>
-            <p:ph type="body" idx="1"/>
-          </p:nvPr>
-        </p:nvSpPr>
-        <p:spPr/>
-        <p:txBody>
-          <a:bodyPr xmlns:a="http://schemas.openxmlformats.org/drawingml/2006/main"/>
-          <a:lstStyle xmlns:a="http://schemas.openxmlformats.org/drawingml/2006/main"/>
-          <a:p xmlns:a="http://schemas.openxmlformats.org/drawingml/2006/main">
-            <a:r>
-              <a:t>這頁可以請學生現場打開工作管理員看虛擬化狀態。先排除環境問題，後面實作會順很多。</a:t>
-            </a:r>
-          </a:p>
-        </p:txBody>
-      </p:sp>
-      <p:sp>
-        <p:nvSpPr>
-          <p:cNvPr id="4" name="Slide Number Placeholder 3"/>
-          <p:cNvSpPr>
-            <a:spLocks xmlns:a="http://schemas.openxmlformats.org/drawingml/2006/main" noGrp="1"/>
-          </p:cNvSpPr>
-          <p:nvPr>
-            <p:ph type="sldNum" idx="5"/>
-          </p:nvPr>
-        </p:nvSpPr>
-        <p:spPr/>
-        <p:txBody>
-          <a:bodyPr xmlns:a="http://schemas.openxmlformats.org/drawingml/2006/main"/>
-          <a:lstStyle xmlns:a="http://schemas.openxmlformats.org/drawingml/2006/main"/>
-          <a:p xmlns:a="http://schemas.openxmlformats.org/drawingml/2006/main"/>
-        </p:txBody>
-      </p:sp>
-    </p:spTree>
-  </p:cSld>
-  <p:clrMapOvr>
-    <a:masterClrMapping xmlns:a="http://schemas.openxmlformats.org/drawingml/2006/main"/>
-  </p:clrMapOvr>
-</p:notes>
-</file>
-
-<file path=ppt/notesSlides/notesSlide12.xml><?xml version="1.0" encoding="utf-8"?>
-<p:notes xmlns:p="http://schemas.openxmlformats.org/presentationml/2006/main">
-  <p:cSld>
-    <p:spTree>
-      <p:nvGrpSpPr>
-        <p:cNvPr id="1" name=""/>
-        <p:cNvGrpSpPr/>
-        <p:nvPr/>
-      </p:nvGrpSpPr>
-      <p:grpSpPr>
-        <a:xfrm xmlns:a="http://schemas.openxmlformats.org/drawingml/2006/main"/>
-      </p:grpSpPr>
-      <p:sp>
-        <p:nvSpPr>
-          <p:cNvPr id="2" name="Slide Image Placeholder 1"/>
-          <p:cNvSpPr>
-            <a:spLocks xmlns:a="http://schemas.openxmlformats.org/drawingml/2006/main" noGrp="1"/>
-          </p:cNvSpPr>
-          <p:nvPr>
-            <p:ph type="sldImg" idx="0"/>
-          </p:nvPr>
-        </p:nvSpPr>
-        <p:spPr/>
-      </p:sp>
-      <p:sp>
-        <p:nvSpPr>
-          <p:cNvPr id="3" name="Notes Placeholder 2"/>
-          <p:cNvSpPr>
-            <a:spLocks xmlns:a="http://schemas.openxmlformats.org/drawingml/2006/main" noGrp="1"/>
-          </p:cNvSpPr>
-          <p:nvPr>
-            <p:ph type="body" idx="1"/>
-          </p:nvPr>
-        </p:nvSpPr>
-        <p:spPr/>
-        <p:txBody>
-          <a:bodyPr xmlns:a="http://schemas.openxmlformats.org/drawingml/2006/main"/>
-          <a:lstStyle xmlns:a="http://schemas.openxmlformats.org/drawingml/2006/main"/>
-          <a:p xmlns:a="http://schemas.openxmlformats.org/drawingml/2006/main">
-            <a:r>
-              <a:t>強調 WSL 2 平常不用手動啟動，Docker Desktop 啟動時會自己使用它。遇到卡住時再用 wsl --shutdown。</a:t>
-            </a:r>
-          </a:p>
-        </p:txBody>
-      </p:sp>
-      <p:sp>
-        <p:nvSpPr>
-          <p:cNvPr id="4" name="Slide Number Placeholder 3"/>
-          <p:cNvSpPr>
-            <a:spLocks xmlns:a="http://schemas.openxmlformats.org/drawingml/2006/main" noGrp="1"/>
-          </p:cNvSpPr>
-          <p:nvPr>
-            <p:ph type="sldNum" idx="5"/>
-          </p:nvPr>
-        </p:nvSpPr>
-        <p:spPr/>
-        <p:txBody>
-          <a:bodyPr xmlns:a="http://schemas.openxmlformats.org/drawingml/2006/main"/>
-          <a:lstStyle xmlns:a="http://schemas.openxmlformats.org/drawingml/2006/main"/>
-          <a:p xmlns:a="http://schemas.openxmlformats.org/drawingml/2006/main"/>
-        </p:txBody>
-      </p:sp>
-    </p:spTree>
-  </p:cSld>
-  <p:clrMapOvr>
-    <a:masterClrMapping xmlns:a="http://schemas.openxmlformats.org/drawingml/2006/main"/>
-  </p:clrMapOvr>
-</p:notes>
-</file>
-
-<file path=ppt/notesSlides/notesSlide13.xml><?xml version="1.0" encoding="utf-8"?>
-<p:notes xmlns:p="http://schemas.openxmlformats.org/presentationml/2006/main">
-  <p:cSld>
-    <p:spTree>
-      <p:nvGrpSpPr>
-        <p:cNvPr id="1" name=""/>
-        <p:cNvGrpSpPr/>
-        <p:nvPr/>
-      </p:nvGrpSpPr>
-      <p:grpSpPr>
-        <a:xfrm xmlns:a="http://schemas.openxmlformats.org/drawingml/2006/main"/>
-      </p:grpSpPr>
-      <p:sp>
-        <p:nvSpPr>
-          <p:cNvPr id="2" name="Slide Image Placeholder 1"/>
-          <p:cNvSpPr>
-            <a:spLocks xmlns:a="http://schemas.openxmlformats.org/drawingml/2006/main" noGrp="1"/>
-          </p:cNvSpPr>
-          <p:nvPr>
-            <p:ph type="sldImg" idx="0"/>
-          </p:nvPr>
-        </p:nvSpPr>
-        <p:spPr/>
-      </p:sp>
-      <p:sp>
-        <p:nvSpPr>
-          <p:cNvPr id="3" name="Notes Placeholder 2"/>
-          <p:cNvSpPr>
-            <a:spLocks xmlns:a="http://schemas.openxmlformats.org/drawingml/2006/main" noGrp="1"/>
-          </p:cNvSpPr>
-          <p:nvPr>
-            <p:ph type="body" idx="1"/>
-          </p:nvPr>
-        </p:nvSpPr>
-        <p:spPr/>
-        <p:txBody>
-          <a:bodyPr xmlns:a="http://schemas.openxmlformats.org/drawingml/2006/main"/>
-          <a:lstStyle xmlns:a="http://schemas.openxmlformats.org/drawingml/2006/main"/>
-          <a:p xmlns:a="http://schemas.openxmlformats.org/drawingml/2006/main">
-            <a:r>
-              <a:t>這頁幫學生建立 GUI 與 CLI 的定位。GUI 不是不能用，但課程要培養能在伺服器與 CI/CD 中工作的能力。</a:t>
-            </a:r>
-          </a:p>
-        </p:txBody>
-      </p:sp>
-      <p:sp>
-        <p:nvSpPr>
-          <p:cNvPr id="4" name="Slide Number Placeholder 3"/>
-          <p:cNvSpPr>
-            <a:spLocks xmlns:a="http://schemas.openxmlformats.org/drawingml/2006/main" noGrp="1"/>
-          </p:cNvSpPr>
-          <p:nvPr>
-            <p:ph type="sldNum" idx="5"/>
-          </p:nvPr>
-        </p:nvSpPr>
-        <p:spPr/>
-        <p:txBody>
-          <a:bodyPr xmlns:a="http://schemas.openxmlformats.org/drawingml/2006/main"/>
-          <a:lstStyle xmlns:a="http://schemas.openxmlformats.org/drawingml/2006/main"/>
-          <a:p xmlns:a="http://schemas.openxmlformats.org/drawingml/2006/main"/>
-        </p:txBody>
-      </p:sp>
-    </p:spTree>
-  </p:cSld>
-  <p:clrMapOvr>
-    <a:masterClrMapping xmlns:a="http://schemas.openxmlformats.org/drawingml/2006/main"/>
-  </p:clrMapOvr>
-</p:notes>
-</file>
-
-<file path=ppt/notesSlides/notesSlide14.xml><?xml version="1.0" encoding="utf-8"?>
-<p:notes xmlns:p="http://schemas.openxmlformats.org/presentationml/2006/main">
-  <p:cSld>
-    <p:spTree>
-      <p:nvGrpSpPr>
-        <p:cNvPr id="1" name=""/>
-        <p:cNvGrpSpPr/>
-        <p:nvPr/>
-      </p:nvGrpSpPr>
-      <p:grpSpPr>
-        <a:xfrm xmlns:a="http://schemas.openxmlformats.org/drawingml/2006/main"/>
-      </p:grpSpPr>
-      <p:sp>
-        <p:nvSpPr>
-          <p:cNvPr id="2" name="Slide Image Placeholder 1"/>
-          <p:cNvSpPr>
-            <a:spLocks xmlns:a="http://schemas.openxmlformats.org/drawingml/2006/main" noGrp="1"/>
-          </p:cNvSpPr>
-          <p:nvPr>
-            <p:ph type="sldImg" idx="0"/>
-          </p:nvPr>
-        </p:nvSpPr>
-        <p:spPr/>
-      </p:sp>
-      <p:sp>
-        <p:nvSpPr>
-          <p:cNvPr id="3" name="Notes Placeholder 2"/>
-          <p:cNvSpPr>
-            <a:spLocks xmlns:a="http://schemas.openxmlformats.org/drawingml/2006/main" noGrp="1"/>
-          </p:cNvSpPr>
-          <p:nvPr>
-            <p:ph type="body" idx="1"/>
-          </p:nvPr>
-        </p:nvSpPr>
-        <p:spPr/>
-        <p:txBody>
-          <a:bodyPr xmlns:a="http://schemas.openxmlformats.org/drawingml/2006/main"/>
-          <a:lstStyle xmlns:a="http://schemas.openxmlformats.org/drawingml/2006/main"/>
-          <a:p xmlns:a="http://schemas.openxmlformats.org/drawingml/2006/main">
-            <a:r>
-              <a:t>hello-world 是第一個完整 Docker 流程，雖然看起來簡單，但已經包含 pull、create、start、stop。</a:t>
-            </a:r>
-          </a:p>
-        </p:txBody>
-      </p:sp>
-      <p:sp>
-        <p:nvSpPr>
-          <p:cNvPr id="4" name="Slide Number Placeholder 3"/>
-          <p:cNvSpPr>
-            <a:spLocks xmlns:a="http://schemas.openxmlformats.org/drawingml/2006/main" noGrp="1"/>
-          </p:cNvSpPr>
-          <p:nvPr>
-            <p:ph type="sldNum" idx="5"/>
-          </p:nvPr>
-        </p:nvSpPr>
-        <p:spPr/>
-        <p:txBody>
-          <a:bodyPr xmlns:a="http://schemas.openxmlformats.org/drawingml/2006/main"/>
-          <a:lstStyle xmlns:a="http://schemas.openxmlformats.org/drawingml/2006/main"/>
-          <a:p xmlns:a="http://schemas.openxmlformats.org/drawingml/2006/main"/>
-        </p:txBody>
-      </p:sp>
-    </p:spTree>
-  </p:cSld>
-  <p:clrMapOvr>
-    <a:masterClrMapping xmlns:a="http://schemas.openxmlformats.org/drawingml/2006/main"/>
-  </p:clrMapOvr>
-</p:notes>
-</file>
-
-<file path=ppt/notesSlides/notesSlide15.xml><?xml version="1.0" encoding="utf-8"?>
-<p:notes xmlns:p="http://schemas.openxmlformats.org/presentationml/2006/main">
-  <p:cSld>
-    <p:spTree>
-      <p:nvGrpSpPr>
-        <p:cNvPr id="1" name=""/>
-        <p:cNvGrpSpPr/>
-        <p:nvPr/>
-      </p:nvGrpSpPr>
-      <p:grpSpPr>
-        <a:xfrm xmlns:a="http://schemas.openxmlformats.org/drawingml/2006/main"/>
-      </p:grpSpPr>
-      <p:sp>
-        <p:nvSpPr>
-          <p:cNvPr id="2" name="Slide Image Placeholder 1"/>
-          <p:cNvSpPr>
-            <a:spLocks xmlns:a="http://schemas.openxmlformats.org/drawingml/2006/main" noGrp="1"/>
-          </p:cNvSpPr>
-          <p:nvPr>
-            <p:ph type="sldImg" idx="0"/>
-          </p:nvPr>
-        </p:nvSpPr>
-        <p:spPr/>
-      </p:sp>
-      <p:sp>
-        <p:nvSpPr>
-          <p:cNvPr id="3" name="Notes Placeholder 2"/>
-          <p:cNvSpPr>
-            <a:spLocks xmlns:a="http://schemas.openxmlformats.org/drawingml/2006/main" noGrp="1"/>
-          </p:cNvSpPr>
-          <p:nvPr>
-            <p:ph type="body" idx="1"/>
-          </p:nvPr>
-        </p:nvSpPr>
-        <p:spPr/>
-        <p:txBody>
-          <a:bodyPr xmlns:a="http://schemas.openxmlformats.org/drawingml/2006/main"/>
-          <a:lstStyle xmlns:a="http://schemas.openxmlformats.org/drawingml/2006/main"/>
-          <a:p xmlns:a="http://schemas.openxmlformats.org/drawingml/2006/main">
-            <a:r>
-              <a:t>這頁先鋪陳後面 Dockerfile 的 build cache。今天只需要學生理解 Image 不是一個大檔案，而是分層。</a:t>
-            </a:r>
-          </a:p>
-        </p:txBody>
-      </p:sp>
-      <p:sp>
-        <p:nvSpPr>
-          <p:cNvPr id="4" name="Slide Number Placeholder 3"/>
-          <p:cNvSpPr>
-            <a:spLocks xmlns:a="http://schemas.openxmlformats.org/drawingml/2006/main" noGrp="1"/>
-          </p:cNvSpPr>
-          <p:nvPr>
-            <p:ph type="sldNum" idx="5"/>
-          </p:nvPr>
-        </p:nvSpPr>
-        <p:spPr/>
-        <p:txBody>
-          <a:bodyPr xmlns:a="http://schemas.openxmlformats.org/drawingml/2006/main"/>
-          <a:lstStyle xmlns:a="http://schemas.openxmlformats.org/drawingml/2006/main"/>
-          <a:p xmlns:a="http://schemas.openxmlformats.org/drawingml/2006/main"/>
-        </p:txBody>
-      </p:sp>
-    </p:spTree>
-  </p:cSld>
-  <p:clrMapOvr>
-    <a:masterClrMapping xmlns:a="http://schemas.openxmlformats.org/drawingml/2006/main"/>
-  </p:clrMapOvr>
-</p:notes>
-</file>
-
-<file path=ppt/notesSlides/notesSlide16.xml><?xml version="1.0" encoding="utf-8"?>
-<p:notes xmlns:p="http://schemas.openxmlformats.org/presentationml/2006/main">
-  <p:cSld>
-    <p:spTree>
-      <p:nvGrpSpPr>
-        <p:cNvPr id="1" name=""/>
-        <p:cNvGrpSpPr/>
-        <p:nvPr/>
-      </p:nvGrpSpPr>
-      <p:grpSpPr>
-        <a:xfrm xmlns:a="http://schemas.openxmlformats.org/drawingml/2006/main"/>
-      </p:grpSpPr>
-      <p:sp>
-        <p:nvSpPr>
-          <p:cNvPr id="2" name="Slide Image Placeholder 1"/>
-          <p:cNvSpPr>
-            <a:spLocks xmlns:a="http://schemas.openxmlformats.org/drawingml/2006/main" noGrp="1"/>
-          </p:cNvSpPr>
-          <p:nvPr>
-            <p:ph type="sldImg" idx="0"/>
-          </p:nvPr>
-        </p:nvSpPr>
-        <p:spPr/>
-      </p:sp>
-      <p:sp>
-        <p:nvSpPr>
-          <p:cNvPr id="3" name="Notes Placeholder 2"/>
-          <p:cNvSpPr>
-            <a:spLocks xmlns:a="http://schemas.openxmlformats.org/drawingml/2006/main" noGrp="1"/>
-          </p:cNvSpPr>
-          <p:nvPr>
-            <p:ph type="body" idx="1"/>
-          </p:nvPr>
-        </p:nvSpPr>
-        <p:spPr/>
-        <p:txBody>
-          <a:bodyPr xmlns:a="http://schemas.openxmlformats.org/drawingml/2006/main"/>
-          <a:lstStyle xmlns:a="http://schemas.openxmlformats.org/drawingml/2006/main"/>
-          <a:p xmlns:a="http://schemas.openxmlformats.org/drawingml/2006/main">
-            <a:r>
-              <a:t>這頁重點是養成查 Docker Hub 官方文件的習慣。不同 Image 的環境變數、路徑、啟動方式都不一樣。</a:t>
-            </a:r>
-          </a:p>
-        </p:txBody>
-      </p:sp>
-      <p:sp>
-        <p:nvSpPr>
-          <p:cNvPr id="4" name="Slide Number Placeholder 3"/>
-          <p:cNvSpPr>
-            <a:spLocks xmlns:a="http://schemas.openxmlformats.org/drawingml/2006/main" noGrp="1"/>
-          </p:cNvSpPr>
-          <p:nvPr>
-            <p:ph type="sldNum" idx="5"/>
-          </p:nvPr>
-        </p:nvSpPr>
-        <p:spPr/>
-        <p:txBody>
-          <a:bodyPr xmlns:a="http://schemas.openxmlformats.org/drawingml/2006/main"/>
-          <a:lstStyle xmlns:a="http://schemas.openxmlformats.org/drawingml/2006/main"/>
-          <a:p xmlns:a="http://schemas.openxmlformats.org/drawingml/2006/main"/>
-        </p:txBody>
-      </p:sp>
-    </p:spTree>
-  </p:cSld>
-  <p:clrMapOvr>
-    <a:masterClrMapping xmlns:a="http://schemas.openxmlformats.org/drawingml/2006/main"/>
-  </p:clrMapOvr>
-</p:notes>
-</file>
-
-<file path=ppt/notesSlides/notesSlide17.xml><?xml version="1.0" encoding="utf-8"?>
-<p:notes xmlns:p="http://schemas.openxmlformats.org/presentationml/2006/main">
-  <p:cSld>
-    <p:spTree>
-      <p:nvGrpSpPr>
-        <p:cNvPr id="1" name=""/>
-        <p:cNvGrpSpPr/>
-        <p:nvPr/>
-      </p:nvGrpSpPr>
-      <p:grpSpPr>
-        <a:xfrm xmlns:a="http://schemas.openxmlformats.org/drawingml/2006/main"/>
-      </p:grpSpPr>
-      <p:sp>
-        <p:nvSpPr>
-          <p:cNvPr id="2" name="Slide Image Placeholder 1"/>
-          <p:cNvSpPr>
-            <a:spLocks xmlns:a="http://schemas.openxmlformats.org/drawingml/2006/main" noGrp="1"/>
-          </p:cNvSpPr>
-          <p:nvPr>
-            <p:ph type="sldImg" idx="0"/>
-          </p:nvPr>
-        </p:nvSpPr>
-        <p:spPr/>
-      </p:sp>
-      <p:sp>
-        <p:nvSpPr>
-          <p:cNvPr id="3" name="Notes Placeholder 2"/>
-          <p:cNvSpPr>
-            <a:spLocks xmlns:a="http://schemas.openxmlformats.org/drawingml/2006/main" noGrp="1"/>
-          </p:cNvSpPr>
-          <p:nvPr>
-            <p:ph type="body" idx="1"/>
-          </p:nvPr>
-        </p:nvSpPr>
-        <p:spPr/>
-        <p:txBody>
-          <a:bodyPr xmlns:a="http://schemas.openxmlformats.org/drawingml/2006/main"/>
-          <a:lstStyle xmlns:a="http://schemas.openxmlformats.org/drawingml/2006/main"/>
-          <a:p xmlns:a="http://schemas.openxmlformats.org/drawingml/2006/main">
-            <a:r>
-              <a:t>提醒 rmi 會失敗的常見原因：還有 container 使用該 Image，不管 container 是執行中或停止狀態。</a:t>
-            </a:r>
-          </a:p>
-        </p:txBody>
-      </p:sp>
-      <p:sp>
-        <p:nvSpPr>
-          <p:cNvPr id="4" name="Slide Number Placeholder 3"/>
-          <p:cNvSpPr>
-            <a:spLocks xmlns:a="http://schemas.openxmlformats.org/drawingml/2006/main" noGrp="1"/>
-          </p:cNvSpPr>
-          <p:nvPr>
-            <p:ph type="sldNum" idx="5"/>
-          </p:nvPr>
-        </p:nvSpPr>
-        <p:spPr/>
-        <p:txBody>
-          <a:bodyPr xmlns:a="http://schemas.openxmlformats.org/drawingml/2006/main"/>
-          <a:lstStyle xmlns:a="http://schemas.openxmlformats.org/drawingml/2006/main"/>
-          <a:p xmlns:a="http://schemas.openxmlformats.org/drawingml/2006/main"/>
-        </p:txBody>
-      </p:sp>
-    </p:spTree>
-  </p:cSld>
-  <p:clrMapOvr>
-    <a:masterClrMapping xmlns:a="http://schemas.openxmlformats.org/drawingml/2006/main"/>
-  </p:clrMapOvr>
-</p:notes>
-</file>
-
-<file path=ppt/notesSlides/notesSlide18.xml><?xml version="1.0" encoding="utf-8"?>
-<p:notes xmlns:p="http://schemas.openxmlformats.org/presentationml/2006/main">
-  <p:cSld>
-    <p:spTree>
-      <p:nvGrpSpPr>
-        <p:cNvPr id="1" name=""/>
-        <p:cNvGrpSpPr/>
-        <p:nvPr/>
-      </p:nvGrpSpPr>
-      <p:grpSpPr>
-        <a:xfrm xmlns:a="http://schemas.openxmlformats.org/drawingml/2006/main"/>
-      </p:grpSpPr>
-      <p:sp>
-        <p:nvSpPr>
-          <p:cNvPr id="2" name="Slide Image Placeholder 1"/>
-          <p:cNvSpPr>
-            <a:spLocks xmlns:a="http://schemas.openxmlformats.org/drawingml/2006/main" noGrp="1"/>
-          </p:cNvSpPr>
-          <p:nvPr>
-            <p:ph type="sldImg" idx="0"/>
-          </p:nvPr>
-        </p:nvSpPr>
-        <p:spPr/>
-      </p:sp>
-      <p:sp>
-        <p:nvSpPr>
-          <p:cNvPr id="3" name="Notes Placeholder 2"/>
-          <p:cNvSpPr>
-            <a:spLocks xmlns:a="http://schemas.openxmlformats.org/drawingml/2006/main" noGrp="1"/>
-          </p:cNvSpPr>
-          <p:nvPr>
-            <p:ph type="body" idx="1"/>
-          </p:nvPr>
-        </p:nvSpPr>
-        <p:spPr/>
-        <p:txBody>
-          <a:bodyPr xmlns:a="http://schemas.openxmlformats.org/drawingml/2006/main"/>
-          <a:lstStyle xmlns:a="http://schemas.openxmlformats.org/drawingml/2006/main"/>
-          <a:p xmlns:a="http://schemas.openxmlformats.org/drawingml/2006/main">
-            <a:r>
-              <a:t>練習題來自 exercises.md 第 1 堂實作題 P1。</a:t>
-            </a:r>
-          </a:p>
-        </p:txBody>
-      </p:sp>
-      <p:sp>
-        <p:nvSpPr>
-          <p:cNvPr id="4" name="Slide Number Placeholder 3"/>
-          <p:cNvSpPr>
-            <a:spLocks xmlns:a="http://schemas.openxmlformats.org/drawingml/2006/main" noGrp="1"/>
-          </p:cNvSpPr>
-          <p:nvPr>
-            <p:ph type="sldNum" idx="5"/>
-          </p:nvPr>
-        </p:nvSpPr>
-        <p:spPr/>
-        <p:txBody>
-          <a:bodyPr xmlns:a="http://schemas.openxmlformats.org/drawingml/2006/main"/>
-          <a:lstStyle xmlns:a="http://schemas.openxmlformats.org/drawingml/2006/main"/>
-          <a:p xmlns:a="http://schemas.openxmlformats.org/drawingml/2006/main"/>
-        </p:txBody>
-      </p:sp>
-    </p:spTree>
-  </p:cSld>
-  <p:clrMapOvr>
-    <a:masterClrMapping xmlns:a="http://schemas.openxmlformats.org/drawingml/2006/main"/>
-  </p:clrMapOvr>
-</p:notes>
-</file>
-
-<file path=ppt/notesSlides/notesSlide19.xml><?xml version="1.0" encoding="utf-8"?>
-<p:notes xmlns:p="http://schemas.openxmlformats.org/presentationml/2006/main">
-  <p:cSld>
-    <p:spTree>
-      <p:nvGrpSpPr>
-        <p:cNvPr id="1" name=""/>
-        <p:cNvGrpSpPr/>
-        <p:nvPr/>
-      </p:nvGrpSpPr>
-      <p:grpSpPr>
-        <a:xfrm xmlns:a="http://schemas.openxmlformats.org/drawingml/2006/main"/>
-      </p:grpSpPr>
-      <p:sp>
-        <p:nvSpPr>
-          <p:cNvPr id="2" name="Slide Image Placeholder 1"/>
-          <p:cNvSpPr>
-            <a:spLocks xmlns:a="http://schemas.openxmlformats.org/drawingml/2006/main" noGrp="1"/>
-          </p:cNvSpPr>
-          <p:nvPr>
-            <p:ph type="sldImg" idx="0"/>
-          </p:nvPr>
-        </p:nvSpPr>
-        <p:spPr/>
-      </p:sp>
-      <p:sp>
-        <p:nvSpPr>
-          <p:cNvPr id="3" name="Notes Placeholder 2"/>
-          <p:cNvSpPr>
-            <a:spLocks xmlns:a="http://schemas.openxmlformats.org/drawingml/2006/main" noGrp="1"/>
-          </p:cNvSpPr>
-          <p:nvPr>
-            <p:ph type="body" idx="1"/>
-          </p:nvPr>
-        </p:nvSpPr>
-        <p:spPr/>
-        <p:txBody>
-          <a:bodyPr xmlns:a="http://schemas.openxmlformats.org/drawingml/2006/main"/>
-          <a:lstStyle xmlns:a="http://schemas.openxmlformats.org/drawingml/2006/main"/>
-          <a:p xmlns:a="http://schemas.openxmlformats.org/drawingml/2006/main">
-            <a:r>
-              <a:t>不要花太多時間講 Nginx 歷史，重點是它在正式上線架構中常站在後端應用前面。</a:t>
-            </a:r>
-          </a:p>
-        </p:txBody>
-      </p:sp>
-      <p:sp>
-        <p:nvSpPr>
-          <p:cNvPr id="4" name="Slide Number Placeholder 3"/>
-          <p:cNvSpPr>
-            <a:spLocks xmlns:a="http://schemas.openxmlformats.org/drawingml/2006/main" noGrp="1"/>
-          </p:cNvSpPr>
-          <p:nvPr>
-            <p:ph type="sldNum" idx="5"/>
-          </p:nvPr>
-        </p:nvSpPr>
-        <p:spPr/>
-        <p:txBody>
-          <a:bodyPr xmlns:a="http://schemas.openxmlformats.org/drawingml/2006/main"/>
-          <a:lstStyle xmlns:a="http://schemas.openxmlformats.org/drawingml/2006/main"/>
-          <a:p xmlns:a="http://schemas.openxmlformats.org/drawingml/2006/main"/>
-        </p:txBody>
-      </p:sp>
-    </p:spTree>
-  </p:cSld>
-  <p:clrMapOvr>
-    <a:masterClrMapping xmlns:a="http://schemas.openxmlformats.org/drawingml/2006/main"/>
-  </p:clrMapOvr>
-</p:notes>
-</file>
-
-<file path=ppt/notesSlides/notesSlide2.xml><?xml version="1.0" encoding="utf-8"?>
-<p:notes xmlns:p="http://schemas.openxmlformats.org/presentationml/2006/main">
-  <p:cSld>
-    <p:spTree>
-      <p:nvGrpSpPr>
-        <p:cNvPr id="1" name=""/>
-        <p:cNvGrpSpPr/>
-        <p:nvPr/>
-      </p:nvGrpSpPr>
-      <p:grpSpPr>
-        <a:xfrm xmlns:a="http://schemas.openxmlformats.org/drawingml/2006/main"/>
-      </p:grpSpPr>
-      <p:sp>
-        <p:nvSpPr>
-          <p:cNvPr id="2" name="Slide Image Placeholder 1"/>
-          <p:cNvSpPr>
-            <a:spLocks xmlns:a="http://schemas.openxmlformats.org/drawingml/2006/main" noGrp="1"/>
-          </p:cNvSpPr>
-          <p:nvPr>
-            <p:ph type="sldImg" idx="0"/>
-          </p:nvPr>
-        </p:nvSpPr>
-        <p:spPr/>
-      </p:sp>
-      <p:sp>
-        <p:nvSpPr>
-          <p:cNvPr id="3" name="Notes Placeholder 2"/>
-          <p:cNvSpPr>
-            <a:spLocks xmlns:a="http://schemas.openxmlformats.org/drawingml/2006/main" noGrp="1"/>
-          </p:cNvSpPr>
-          <p:nvPr>
-            <p:ph type="body" idx="1"/>
-          </p:nvPr>
-        </p:nvSpPr>
-        <p:spPr/>
-        <p:txBody>
-          <a:bodyPr xmlns:a="http://schemas.openxmlformats.org/drawingml/2006/main"/>
-          <a:lstStyle xmlns:a="http://schemas.openxmlformats.org/drawingml/2006/main"/>
-          <a:p xmlns:a="http://schemas.openxmlformats.org/drawingml/2006/main">
-            <a:r>
-              <a:t>讓學生知道節奏：先概念、再安裝、最後跑 Nginx。每一段都應該搭配現場操作或檢查。</a:t>
-            </a:r>
-          </a:p>
-        </p:txBody>
-      </p:sp>
-      <p:sp>
-        <p:nvSpPr>
-          <p:cNvPr id="4" name="Slide Number Placeholder 3"/>
-          <p:cNvSpPr>
-            <a:spLocks xmlns:a="http://schemas.openxmlformats.org/drawingml/2006/main" noGrp="1"/>
-          </p:cNvSpPr>
-          <p:nvPr>
-            <p:ph type="sldNum" idx="5"/>
-          </p:nvPr>
-        </p:nvSpPr>
-        <p:spPr/>
-        <p:txBody>
-          <a:bodyPr xmlns:a="http://schemas.openxmlformats.org/drawingml/2006/main"/>
-          <a:lstStyle xmlns:a="http://schemas.openxmlformats.org/drawingml/2006/main"/>
-          <a:p xmlns:a="http://schemas.openxmlformats.org/drawingml/2006/main"/>
-        </p:txBody>
-      </p:sp>
-    </p:spTree>
-  </p:cSld>
-  <p:clrMapOvr>
-    <a:masterClrMapping xmlns:a="http://schemas.openxmlformats.org/drawingml/2006/main"/>
-  </p:clrMapOvr>
-</p:notes>
-</file>
-
-<file path=ppt/notesSlides/notesSlide20.xml><?xml version="1.0" encoding="utf-8"?>
-<p:notes xmlns:p="http://schemas.openxmlformats.org/presentationml/2006/main">
-  <p:cSld>
-    <p:spTree>
-      <p:nvGrpSpPr>
-        <p:cNvPr id="1" name=""/>
-        <p:cNvGrpSpPr/>
-        <p:nvPr/>
-      </p:nvGrpSpPr>
-      <p:grpSpPr>
-        <a:xfrm xmlns:a="http://schemas.openxmlformats.org/drawingml/2006/main"/>
-      </p:grpSpPr>
-      <p:sp>
-        <p:nvSpPr>
-          <p:cNvPr id="2" name="Slide Image Placeholder 1"/>
-          <p:cNvSpPr>
-            <a:spLocks xmlns:a="http://schemas.openxmlformats.org/drawingml/2006/main" noGrp="1"/>
-          </p:cNvSpPr>
-          <p:nvPr>
-            <p:ph type="sldImg" idx="0"/>
-          </p:nvPr>
-        </p:nvSpPr>
-        <p:spPr/>
-      </p:sp>
-      <p:sp>
-        <p:nvSpPr>
-          <p:cNvPr id="3" name="Notes Placeholder 2"/>
-          <p:cNvSpPr>
-            <a:spLocks xmlns:a="http://schemas.openxmlformats.org/drawingml/2006/main" noGrp="1"/>
-          </p:cNvSpPr>
-          <p:nvPr>
-            <p:ph type="body" idx="1"/>
-          </p:nvPr>
-        </p:nvSpPr>
-        <p:spPr/>
-        <p:txBody>
-          <a:bodyPr xmlns:a="http://schemas.openxmlformats.org/drawingml/2006/main"/>
-          <a:lstStyle xmlns:a="http://schemas.openxmlformats.org/drawingml/2006/main"/>
-          <a:p xmlns:a="http://schemas.openxmlformats.org/drawingml/2006/main">
-            <a:r>
-              <a:t>這頁是防止初學者誤解 localhost。正式上線還需要網域、憑證、部署和長時間運行的伺服器。</a:t>
-            </a:r>
-          </a:p>
-        </p:txBody>
-      </p:sp>
-      <p:sp>
-        <p:nvSpPr>
-          <p:cNvPr id="4" name="Slide Number Placeholder 3"/>
-          <p:cNvSpPr>
-            <a:spLocks xmlns:a="http://schemas.openxmlformats.org/drawingml/2006/main" noGrp="1"/>
-          </p:cNvSpPr>
-          <p:nvPr>
-            <p:ph type="sldNum" idx="5"/>
-          </p:nvPr>
-        </p:nvSpPr>
-        <p:spPr/>
-        <p:txBody>
-          <a:bodyPr xmlns:a="http://schemas.openxmlformats.org/drawingml/2006/main"/>
-          <a:lstStyle xmlns:a="http://schemas.openxmlformats.org/drawingml/2006/main"/>
-          <a:p xmlns:a="http://schemas.openxmlformats.org/drawingml/2006/main"/>
-        </p:txBody>
-      </p:sp>
-    </p:spTree>
-  </p:cSld>
-  <p:clrMapOvr>
-    <a:masterClrMapping xmlns:a="http://schemas.openxmlformats.org/drawingml/2006/main"/>
-  </p:clrMapOvr>
-</p:notes>
-</file>
-
-<file path=ppt/notesSlides/notesSlide21.xml><?xml version="1.0" encoding="utf-8"?>
-<p:notes xmlns:p="http://schemas.openxmlformats.org/presentationml/2006/main">
-  <p:cSld>
-    <p:spTree>
-      <p:nvGrpSpPr>
-        <p:cNvPr id="1" name=""/>
-        <p:cNvGrpSpPr/>
-        <p:nvPr/>
-      </p:nvGrpSpPr>
-      <p:grpSpPr>
-        <a:xfrm xmlns:a="http://schemas.openxmlformats.org/drawingml/2006/main"/>
-      </p:grpSpPr>
-      <p:sp>
-        <p:nvSpPr>
-          <p:cNvPr id="2" name="Slide Image Placeholder 1"/>
-          <p:cNvSpPr>
-            <a:spLocks xmlns:a="http://schemas.openxmlformats.org/drawingml/2006/main" noGrp="1"/>
-          </p:cNvSpPr>
-          <p:nvPr>
-            <p:ph type="sldImg" idx="0"/>
-          </p:nvPr>
-        </p:nvSpPr>
-        <p:spPr/>
-      </p:sp>
-      <p:sp>
-        <p:nvSpPr>
-          <p:cNvPr id="3" name="Notes Placeholder 2"/>
-          <p:cNvSpPr>
-            <a:spLocks xmlns:a="http://schemas.openxmlformats.org/drawingml/2006/main" noGrp="1"/>
-          </p:cNvSpPr>
-          <p:nvPr>
-            <p:ph type="body" idx="1"/>
-          </p:nvPr>
-        </p:nvSpPr>
-        <p:spPr/>
-        <p:txBody>
-          <a:bodyPr xmlns:a="http://schemas.openxmlformats.org/drawingml/2006/main"/>
-          <a:lstStyle xmlns:a="http://schemas.openxmlformats.org/drawingml/2006/main"/>
-          <a:p xmlns:a="http://schemas.openxmlformats.org/drawingml/2006/main">
-            <a:r>
-              <a:t>強調 -p 和 -v 都是主機:容器。Windows 路徑使用 -v 時要用雙引號，這在後續 Volume 會很重要。</a:t>
-            </a:r>
-          </a:p>
-        </p:txBody>
-      </p:sp>
-      <p:sp>
-        <p:nvSpPr>
-          <p:cNvPr id="4" name="Slide Number Placeholder 3"/>
-          <p:cNvSpPr>
-            <a:spLocks xmlns:a="http://schemas.openxmlformats.org/drawingml/2006/main" noGrp="1"/>
-          </p:cNvSpPr>
-          <p:nvPr>
-            <p:ph type="sldNum" idx="5"/>
-          </p:nvPr>
-        </p:nvSpPr>
-        <p:spPr/>
-        <p:txBody>
-          <a:bodyPr xmlns:a="http://schemas.openxmlformats.org/drawingml/2006/main"/>
-          <a:lstStyle xmlns:a="http://schemas.openxmlformats.org/drawingml/2006/main"/>
-          <a:p xmlns:a="http://schemas.openxmlformats.org/drawingml/2006/main"/>
-        </p:txBody>
-      </p:sp>
-    </p:spTree>
-  </p:cSld>
-  <p:clrMapOvr>
-    <a:masterClrMapping xmlns:a="http://schemas.openxmlformats.org/drawingml/2006/main"/>
-  </p:clrMapOvr>
-</p:notes>
-</file>
-
-<file path=ppt/notesSlides/notesSlide22.xml><?xml version="1.0" encoding="utf-8"?>
-<p:notes xmlns:p="http://schemas.openxmlformats.org/presentationml/2006/main">
-  <p:cSld>
-    <p:spTree>
-      <p:nvGrpSpPr>
-        <p:cNvPr id="1" name=""/>
-        <p:cNvGrpSpPr/>
-        <p:nvPr/>
-      </p:nvGrpSpPr>
-      <p:grpSpPr>
-        <a:xfrm xmlns:a="http://schemas.openxmlformats.org/drawingml/2006/main"/>
-      </p:grpSpPr>
-      <p:sp>
-        <p:nvSpPr>
-          <p:cNvPr id="2" name="Slide Image Placeholder 1"/>
-          <p:cNvSpPr>
-            <a:spLocks xmlns:a="http://schemas.openxmlformats.org/drawingml/2006/main" noGrp="1"/>
-          </p:cNvSpPr>
-          <p:nvPr>
-            <p:ph type="sldImg" idx="0"/>
-          </p:nvPr>
-        </p:nvSpPr>
-        <p:spPr/>
-      </p:sp>
-      <p:sp>
-        <p:nvSpPr>
-          <p:cNvPr id="3" name="Notes Placeholder 2"/>
-          <p:cNvSpPr>
-            <a:spLocks xmlns:a="http://schemas.openxmlformats.org/drawingml/2006/main" noGrp="1"/>
-          </p:cNvSpPr>
-          <p:nvPr>
-            <p:ph type="body" idx="1"/>
-          </p:nvPr>
-        </p:nvSpPr>
-        <p:spPr/>
-        <p:txBody>
-          <a:bodyPr xmlns:a="http://schemas.openxmlformats.org/drawingml/2006/main"/>
-          <a:lstStyle xmlns:a="http://schemas.openxmlformats.org/drawingml/2006/main"/>
-          <a:p xmlns:a="http://schemas.openxmlformats.org/drawingml/2006/main">
-            <a:r>
-              <a:t>這頁建議現場直接執行。先讓學生理解每個參數，再貼上完整指令。</a:t>
-            </a:r>
-          </a:p>
-        </p:txBody>
-      </p:sp>
-      <p:sp>
-        <p:nvSpPr>
-          <p:cNvPr id="4" name="Slide Number Placeholder 3"/>
-          <p:cNvSpPr>
-            <a:spLocks xmlns:a="http://schemas.openxmlformats.org/drawingml/2006/main" noGrp="1"/>
-          </p:cNvSpPr>
-          <p:nvPr>
-            <p:ph type="sldNum" idx="5"/>
-          </p:nvPr>
-        </p:nvSpPr>
-        <p:spPr/>
-        <p:txBody>
-          <a:bodyPr xmlns:a="http://schemas.openxmlformats.org/drawingml/2006/main"/>
-          <a:lstStyle xmlns:a="http://schemas.openxmlformats.org/drawingml/2006/main"/>
-          <a:p xmlns:a="http://schemas.openxmlformats.org/drawingml/2006/main"/>
-        </p:txBody>
-      </p:sp>
-    </p:spTree>
-  </p:cSld>
-  <p:clrMapOvr>
-    <a:masterClrMapping xmlns:a="http://schemas.openxmlformats.org/drawingml/2006/main"/>
-  </p:clrMapOvr>
-</p:notes>
-</file>
-
-<file path=ppt/notesSlides/notesSlide23.xml><?xml version="1.0" encoding="utf-8"?>
-<p:notes xmlns:p="http://schemas.openxmlformats.org/presentationml/2006/main">
-  <p:cSld>
-    <p:spTree>
-      <p:nvGrpSpPr>
-        <p:cNvPr id="1" name=""/>
-        <p:cNvGrpSpPr/>
-        <p:nvPr/>
-      </p:nvGrpSpPr>
-      <p:grpSpPr>
-        <a:xfrm xmlns:a="http://schemas.openxmlformats.org/drawingml/2006/main"/>
-      </p:grpSpPr>
-      <p:sp>
-        <p:nvSpPr>
-          <p:cNvPr id="2" name="Slide Image Placeholder 1"/>
-          <p:cNvSpPr>
-            <a:spLocks xmlns:a="http://schemas.openxmlformats.org/drawingml/2006/main" noGrp="1"/>
-          </p:cNvSpPr>
-          <p:nvPr>
-            <p:ph type="sldImg" idx="0"/>
-          </p:nvPr>
-        </p:nvSpPr>
-        <p:spPr/>
-      </p:sp>
-      <p:sp>
-        <p:nvSpPr>
-          <p:cNvPr id="3" name="Notes Placeholder 2"/>
-          <p:cNvSpPr>
-            <a:spLocks xmlns:a="http://schemas.openxmlformats.org/drawingml/2006/main" noGrp="1"/>
-          </p:cNvSpPr>
-          <p:nvPr>
-            <p:ph type="body" idx="1"/>
-          </p:nvPr>
-        </p:nvSpPr>
-        <p:spPr/>
-        <p:txBody>
-          <a:bodyPr xmlns:a="http://schemas.openxmlformats.org/drawingml/2006/main"/>
-          <a:lstStyle xmlns:a="http://schemas.openxmlformats.org/drawingml/2006/main"/>
-          <a:p xmlns:a="http://schemas.openxmlformats.org/drawingml/2006/main">
-            <a:r>
-              <a:t>如果看不到頁面，優先檢查 Docker Desktop 是否正在執行、容器是否 Up、8080 port 是否被其他程式佔用。</a:t>
-            </a:r>
-          </a:p>
-        </p:txBody>
-      </p:sp>
-      <p:sp>
-        <p:nvSpPr>
-          <p:cNvPr id="4" name="Slide Number Placeholder 3"/>
-          <p:cNvSpPr>
-            <a:spLocks xmlns:a="http://schemas.openxmlformats.org/drawingml/2006/main" noGrp="1"/>
-          </p:cNvSpPr>
-          <p:nvPr>
-            <p:ph type="sldNum" idx="5"/>
-          </p:nvPr>
-        </p:nvSpPr>
-        <p:spPr/>
-        <p:txBody>
-          <a:bodyPr xmlns:a="http://schemas.openxmlformats.org/drawingml/2006/main"/>
-          <a:lstStyle xmlns:a="http://schemas.openxmlformats.org/drawingml/2006/main"/>
-          <a:p xmlns:a="http://schemas.openxmlformats.org/drawingml/2006/main"/>
-        </p:txBody>
-      </p:sp>
-    </p:spTree>
-  </p:cSld>
-  <p:clrMapOvr>
-    <a:masterClrMapping xmlns:a="http://schemas.openxmlformats.org/drawingml/2006/main"/>
-  </p:clrMapOvr>
-</p:notes>
-</file>
-
-<file path=ppt/notesSlides/notesSlide24.xml><?xml version="1.0" encoding="utf-8"?>
-<p:notes xmlns:p="http://schemas.openxmlformats.org/presentationml/2006/main">
-  <p:cSld>
-    <p:spTree>
-      <p:nvGrpSpPr>
-        <p:cNvPr id="1" name=""/>
-        <p:cNvGrpSpPr/>
-        <p:nvPr/>
-      </p:nvGrpSpPr>
-      <p:grpSpPr>
-        <a:xfrm xmlns:a="http://schemas.openxmlformats.org/drawingml/2006/main"/>
-      </p:grpSpPr>
-      <p:sp>
-        <p:nvSpPr>
-          <p:cNvPr id="2" name="Slide Image Placeholder 1"/>
-          <p:cNvSpPr>
-            <a:spLocks xmlns:a="http://schemas.openxmlformats.org/drawingml/2006/main" noGrp="1"/>
-          </p:cNvSpPr>
-          <p:nvPr>
-            <p:ph type="sldImg" idx="0"/>
-          </p:nvPr>
-        </p:nvSpPr>
-        <p:spPr/>
-      </p:sp>
-      <p:sp>
-        <p:nvSpPr>
-          <p:cNvPr id="3" name="Notes Placeholder 2"/>
-          <p:cNvSpPr>
-            <a:spLocks xmlns:a="http://schemas.openxmlformats.org/drawingml/2006/main" noGrp="1"/>
-          </p:cNvSpPr>
-          <p:nvPr>
-            <p:ph type="body" idx="1"/>
-          </p:nvPr>
-        </p:nvSpPr>
-        <p:spPr/>
-        <p:txBody>
-          <a:bodyPr xmlns:a="http://schemas.openxmlformats.org/drawingml/2006/main"/>
-          <a:lstStyle xmlns:a="http://schemas.openxmlformats.org/drawingml/2006/main"/>
-          <a:p xmlns:a="http://schemas.openxmlformats.org/drawingml/2006/main">
-            <a:r>
-              <a:t>Nginx image 使用 sh 而不是 bash。這裡讓學生知道容器可以進去看，但它的檔案系統和 Windows 是分開的。</a:t>
-            </a:r>
-          </a:p>
-        </p:txBody>
-      </p:sp>
-      <p:sp>
-        <p:nvSpPr>
-          <p:cNvPr id="4" name="Slide Number Placeholder 3"/>
-          <p:cNvSpPr>
-            <a:spLocks xmlns:a="http://schemas.openxmlformats.org/drawingml/2006/main" noGrp="1"/>
-          </p:cNvSpPr>
-          <p:nvPr>
-            <p:ph type="sldNum" idx="5"/>
-          </p:nvPr>
-        </p:nvSpPr>
-        <p:spPr/>
-        <p:txBody>
-          <a:bodyPr xmlns:a="http://schemas.openxmlformats.org/drawingml/2006/main"/>
-          <a:lstStyle xmlns:a="http://schemas.openxmlformats.org/drawingml/2006/main"/>
-          <a:p xmlns:a="http://schemas.openxmlformats.org/drawingml/2006/main"/>
-        </p:txBody>
-      </p:sp>
-    </p:spTree>
-  </p:cSld>
-  <p:clrMapOvr>
-    <a:masterClrMapping xmlns:a="http://schemas.openxmlformats.org/drawingml/2006/main"/>
-  </p:clrMapOvr>
-</p:notes>
-</file>
-
-<file path=ppt/notesSlides/notesSlide25.xml><?xml version="1.0" encoding="utf-8"?>
-<p:notes xmlns:p="http://schemas.openxmlformats.org/presentationml/2006/main">
-  <p:cSld>
-    <p:spTree>
-      <p:nvGrpSpPr>
-        <p:cNvPr id="1" name=""/>
-        <p:cNvGrpSpPr/>
-        <p:nvPr/>
-      </p:nvGrpSpPr>
-      <p:grpSpPr>
-        <a:xfrm xmlns:a="http://schemas.openxmlformats.org/drawingml/2006/main"/>
-      </p:grpSpPr>
-      <p:sp>
-        <p:nvSpPr>
-          <p:cNvPr id="2" name="Slide Image Placeholder 1"/>
-          <p:cNvSpPr>
-            <a:spLocks xmlns:a="http://schemas.openxmlformats.org/drawingml/2006/main" noGrp="1"/>
-          </p:cNvSpPr>
-          <p:nvPr>
-            <p:ph type="sldImg" idx="0"/>
-          </p:nvPr>
-        </p:nvSpPr>
-        <p:spPr/>
-      </p:sp>
-      <p:sp>
-        <p:nvSpPr>
-          <p:cNvPr id="3" name="Notes Placeholder 2"/>
-          <p:cNvSpPr>
-            <a:spLocks xmlns:a="http://schemas.openxmlformats.org/drawingml/2006/main" noGrp="1"/>
-          </p:cNvSpPr>
-          <p:nvPr>
-            <p:ph type="body" idx="1"/>
-          </p:nvPr>
-        </p:nvSpPr>
-        <p:spPr/>
-        <p:txBody>
-          <a:bodyPr xmlns:a="http://schemas.openxmlformats.org/drawingml/2006/main"/>
-          <a:lstStyle xmlns:a="http://schemas.openxmlformats.org/drawingml/2006/main"/>
-          <a:p xmlns:a="http://schemas.openxmlformats.org/drawingml/2006/main">
-            <a:r>
-              <a:t>練習題來自 exercises.md 第 1 堂實作題 P2。也對應 docker-course-examples/session-01-basics/p2-nginx-custom-page。</a:t>
-            </a:r>
-          </a:p>
-        </p:txBody>
-      </p:sp>
-      <p:sp>
-        <p:nvSpPr>
-          <p:cNvPr id="4" name="Slide Number Placeholder 3"/>
-          <p:cNvSpPr>
-            <a:spLocks xmlns:a="http://schemas.openxmlformats.org/drawingml/2006/main" noGrp="1"/>
-          </p:cNvSpPr>
-          <p:nvPr>
-            <p:ph type="sldNum" idx="5"/>
-          </p:nvPr>
-        </p:nvSpPr>
-        <p:spPr/>
-        <p:txBody>
-          <a:bodyPr xmlns:a="http://schemas.openxmlformats.org/drawingml/2006/main"/>
-          <a:lstStyle xmlns:a="http://schemas.openxmlformats.org/drawingml/2006/main"/>
-          <a:p xmlns:a="http://schemas.openxmlformats.org/drawingml/2006/main"/>
-        </p:txBody>
-      </p:sp>
-    </p:spTree>
-  </p:cSld>
-  <p:clrMapOvr>
-    <a:masterClrMapping xmlns:a="http://schemas.openxmlformats.org/drawingml/2006/main"/>
-  </p:clrMapOvr>
-</p:notes>
-</file>
-
-<file path=ppt/notesSlides/notesSlide26.xml><?xml version="1.0" encoding="utf-8"?>
-<p:notes xmlns:p="http://schemas.openxmlformats.org/presentationml/2006/main">
-  <p:cSld>
-    <p:spTree>
-      <p:nvGrpSpPr>
-        <p:cNvPr id="1" name=""/>
-        <p:cNvGrpSpPr/>
-        <p:nvPr/>
-      </p:nvGrpSpPr>
-      <p:grpSpPr>
-        <a:xfrm xmlns:a="http://schemas.openxmlformats.org/drawingml/2006/main"/>
-      </p:grpSpPr>
-      <p:sp>
-        <p:nvSpPr>
-          <p:cNvPr id="2" name="Slide Image Placeholder 1"/>
-          <p:cNvSpPr>
-            <a:spLocks xmlns:a="http://schemas.openxmlformats.org/drawingml/2006/main" noGrp="1"/>
-          </p:cNvSpPr>
-          <p:nvPr>
-            <p:ph type="sldImg" idx="0"/>
-          </p:nvPr>
-        </p:nvSpPr>
-        <p:spPr/>
-      </p:sp>
-      <p:sp>
-        <p:nvSpPr>
-          <p:cNvPr id="3" name="Notes Placeholder 2"/>
-          <p:cNvSpPr>
-            <a:spLocks xmlns:a="http://schemas.openxmlformats.org/drawingml/2006/main" noGrp="1"/>
-          </p:cNvSpPr>
-          <p:nvPr>
-            <p:ph type="body" idx="1"/>
-          </p:nvPr>
-        </p:nvSpPr>
-        <p:spPr/>
-        <p:txBody>
-          <a:bodyPr xmlns:a="http://schemas.openxmlformats.org/drawingml/2006/main"/>
-          <a:lstStyle xmlns:a="http://schemas.openxmlformats.org/drawingml/2006/main"/>
-          <a:p xmlns:a="http://schemas.openxmlformats.org/drawingml/2006/main">
-            <a:r>
-              <a:t>這頁收斂成日常排查流程。初學者最常見問題是容器名稱重複、port 被佔用、Image 刪不掉。</a:t>
-            </a:r>
-          </a:p>
-        </p:txBody>
-      </p:sp>
-      <p:sp>
-        <p:nvSpPr>
-          <p:cNvPr id="4" name="Slide Number Placeholder 3"/>
-          <p:cNvSpPr>
-            <a:spLocks xmlns:a="http://schemas.openxmlformats.org/drawingml/2006/main" noGrp="1"/>
-          </p:cNvSpPr>
-          <p:nvPr>
-            <p:ph type="sldNum" idx="5"/>
-          </p:nvPr>
-        </p:nvSpPr>
-        <p:spPr/>
-        <p:txBody>
-          <a:bodyPr xmlns:a="http://schemas.openxmlformats.org/drawingml/2006/main"/>
-          <a:lstStyle xmlns:a="http://schemas.openxmlformats.org/drawingml/2006/main"/>
-          <a:p xmlns:a="http://schemas.openxmlformats.org/drawingml/2006/main"/>
-        </p:txBody>
-      </p:sp>
-    </p:spTree>
-  </p:cSld>
-  <p:clrMapOvr>
-    <a:masterClrMapping xmlns:a="http://schemas.openxmlformats.org/drawingml/2006/main"/>
-  </p:clrMapOvr>
-</p:notes>
-</file>
-
-<file path=ppt/notesSlides/notesSlide27.xml><?xml version="1.0" encoding="utf-8"?>
-<p:notes xmlns:p="http://schemas.openxmlformats.org/presentationml/2006/main">
-  <p:cSld>
-    <p:spTree>
-      <p:nvGrpSpPr>
-        <p:cNvPr id="1" name=""/>
-        <p:cNvGrpSpPr/>
-        <p:nvPr/>
-      </p:nvGrpSpPr>
-      <p:grpSpPr>
-        <a:xfrm xmlns:a="http://schemas.openxmlformats.org/drawingml/2006/main"/>
-      </p:grpSpPr>
-      <p:sp>
-        <p:nvSpPr>
-          <p:cNvPr id="2" name="Slide Image Placeholder 1"/>
-          <p:cNvSpPr>
-            <a:spLocks xmlns:a="http://schemas.openxmlformats.org/drawingml/2006/main" noGrp="1"/>
-          </p:cNvSpPr>
-          <p:nvPr>
-            <p:ph type="sldImg" idx="0"/>
-          </p:nvPr>
-        </p:nvSpPr>
-        <p:spPr/>
-      </p:sp>
-      <p:sp>
-        <p:nvSpPr>
-          <p:cNvPr id="3" name="Notes Placeholder 2"/>
-          <p:cNvSpPr>
-            <a:spLocks xmlns:a="http://schemas.openxmlformats.org/drawingml/2006/main" noGrp="1"/>
-          </p:cNvSpPr>
-          <p:nvPr>
-            <p:ph type="body" idx="1"/>
-          </p:nvPr>
-        </p:nvSpPr>
-        <p:spPr/>
-        <p:txBody>
-          <a:bodyPr xmlns:a="http://schemas.openxmlformats.org/drawingml/2006/main"/>
-          <a:lstStyle xmlns:a="http://schemas.openxmlformats.org/drawingml/2006/main"/>
-          <a:p xmlns:a="http://schemas.openxmlformats.org/drawingml/2006/main">
-            <a:r>
-              <a:t>練習題來自 exercises.md 第 1 堂實作題 P3 與挑戰題 C1。</a:t>
-            </a:r>
-          </a:p>
-        </p:txBody>
-      </p:sp>
-      <p:sp>
-        <p:nvSpPr>
-          <p:cNvPr id="4" name="Slide Number Placeholder 3"/>
-          <p:cNvSpPr>
-            <a:spLocks xmlns:a="http://schemas.openxmlformats.org/drawingml/2006/main" noGrp="1"/>
-          </p:cNvSpPr>
-          <p:nvPr>
-            <p:ph type="sldNum" idx="5"/>
-          </p:nvPr>
-        </p:nvSpPr>
-        <p:spPr/>
-        <p:txBody>
-          <a:bodyPr xmlns:a="http://schemas.openxmlformats.org/drawingml/2006/main"/>
-          <a:lstStyle xmlns:a="http://schemas.openxmlformats.org/drawingml/2006/main"/>
-          <a:p xmlns:a="http://schemas.openxmlformats.org/drawingml/2006/main"/>
-        </p:txBody>
-      </p:sp>
-    </p:spTree>
-  </p:cSld>
-  <p:clrMapOvr>
-    <a:masterClrMapping xmlns:a="http://schemas.openxmlformats.org/drawingml/2006/main"/>
-  </p:clrMapOvr>
-</p:notes>
-</file>
-
-<file path=ppt/notesSlides/notesSlide3.xml><?xml version="1.0" encoding="utf-8"?>
-<p:notes xmlns:p="http://schemas.openxmlformats.org/presentationml/2006/main">
-  <p:cSld>
-    <p:spTree>
-      <p:nvGrpSpPr>
-        <p:cNvPr id="1" name=""/>
-        <p:cNvGrpSpPr/>
-        <p:nvPr/>
-      </p:nvGrpSpPr>
-      <p:grpSpPr>
-        <a:xfrm xmlns:a="http://schemas.openxmlformats.org/drawingml/2006/main"/>
-      </p:grpSpPr>
-      <p:sp>
-        <p:nvSpPr>
-          <p:cNvPr id="2" name="Slide Image Placeholder 1"/>
-          <p:cNvSpPr>
-            <a:spLocks xmlns:a="http://schemas.openxmlformats.org/drawingml/2006/main" noGrp="1"/>
-          </p:cNvSpPr>
-          <p:nvPr>
-            <p:ph type="sldImg" idx="0"/>
-          </p:nvPr>
-        </p:nvSpPr>
-        <p:spPr/>
-      </p:sp>
-      <p:sp>
-        <p:nvSpPr>
-          <p:cNvPr id="3" name="Notes Placeholder 2"/>
-          <p:cNvSpPr>
-            <a:spLocks xmlns:a="http://schemas.openxmlformats.org/drawingml/2006/main" noGrp="1"/>
-          </p:cNvSpPr>
-          <p:nvPr>
-            <p:ph type="body" idx="1"/>
-          </p:nvPr>
-        </p:nvSpPr>
-        <p:spPr/>
-        <p:txBody>
-          <a:bodyPr xmlns:a="http://schemas.openxmlformats.org/drawingml/2006/main"/>
-          <a:lstStyle xmlns:a="http://schemas.openxmlformats.org/drawingml/2006/main"/>
-          <a:p xmlns:a="http://schemas.openxmlformats.org/drawingml/2006/main">
-            <a:r>
-              <a:t>用講義的搬家比喻或自己的部署經驗帶入。重點是 Docker 不只是方便，而是降低環境差異造成的部署失敗。</a:t>
-            </a:r>
-          </a:p>
-        </p:txBody>
-      </p:sp>
-      <p:sp>
-        <p:nvSpPr>
-          <p:cNvPr id="4" name="Slide Number Placeholder 3"/>
-          <p:cNvSpPr>
-            <a:spLocks xmlns:a="http://schemas.openxmlformats.org/drawingml/2006/main" noGrp="1"/>
-          </p:cNvSpPr>
-          <p:nvPr>
-            <p:ph type="sldNum" idx="5"/>
-          </p:nvPr>
-        </p:nvSpPr>
-        <p:spPr/>
-        <p:txBody>
-          <a:bodyPr xmlns:a="http://schemas.openxmlformats.org/drawingml/2006/main"/>
-          <a:lstStyle xmlns:a="http://schemas.openxmlformats.org/drawingml/2006/main"/>
-          <a:p xmlns:a="http://schemas.openxmlformats.org/drawingml/2006/main"/>
-        </p:txBody>
-      </p:sp>
-    </p:spTree>
-  </p:cSld>
-  <p:clrMapOvr>
-    <a:masterClrMapping xmlns:a="http://schemas.openxmlformats.org/drawingml/2006/main"/>
-  </p:clrMapOvr>
-</p:notes>
-</file>
-
-<file path=ppt/notesSlides/notesSlide4.xml><?xml version="1.0" encoding="utf-8"?>
-<p:notes xmlns:p="http://schemas.openxmlformats.org/presentationml/2006/main">
-  <p:cSld>
-    <p:spTree>
-      <p:nvGrpSpPr>
-        <p:cNvPr id="1" name=""/>
-        <p:cNvGrpSpPr/>
-        <p:nvPr/>
-      </p:nvGrpSpPr>
-      <p:grpSpPr>
-        <a:xfrm xmlns:a="http://schemas.openxmlformats.org/drawingml/2006/main"/>
-      </p:grpSpPr>
-      <p:sp>
-        <p:nvSpPr>
-          <p:cNvPr id="2" name="Slide Image Placeholder 1"/>
-          <p:cNvSpPr>
-            <a:spLocks xmlns:a="http://schemas.openxmlformats.org/drawingml/2006/main" noGrp="1"/>
-          </p:cNvSpPr>
-          <p:nvPr>
-            <p:ph type="sldImg" idx="0"/>
-          </p:nvPr>
-        </p:nvSpPr>
-        <p:spPr/>
-      </p:sp>
-      <p:sp>
-        <p:nvSpPr>
-          <p:cNvPr id="3" name="Notes Placeholder 2"/>
-          <p:cNvSpPr>
-            <a:spLocks xmlns:a="http://schemas.openxmlformats.org/drawingml/2006/main" noGrp="1"/>
-          </p:cNvSpPr>
-          <p:nvPr>
-            <p:ph type="body" idx="1"/>
-          </p:nvPr>
-        </p:nvSpPr>
-        <p:spPr/>
-        <p:txBody>
-          <a:bodyPr xmlns:a="http://schemas.openxmlformats.org/drawingml/2006/main"/>
-          <a:lstStyle xmlns:a="http://schemas.openxmlformats.org/drawingml/2006/main"/>
-          <a:p xmlns:a="http://schemas.openxmlformats.org/drawingml/2006/main">
-            <a:r>
-              <a:t>不要過度深入 Linux kernel；初學者只要記住容器不是 VM，它共用主機核心，所以比較輕、比較快。</a:t>
-            </a:r>
-          </a:p>
-        </p:txBody>
-      </p:sp>
-      <p:sp>
-        <p:nvSpPr>
-          <p:cNvPr id="4" name="Slide Number Placeholder 3"/>
-          <p:cNvSpPr>
-            <a:spLocks xmlns:a="http://schemas.openxmlformats.org/drawingml/2006/main" noGrp="1"/>
-          </p:cNvSpPr>
-          <p:nvPr>
-            <p:ph type="sldNum" idx="5"/>
-          </p:nvPr>
-        </p:nvSpPr>
-        <p:spPr/>
-        <p:txBody>
-          <a:bodyPr xmlns:a="http://schemas.openxmlformats.org/drawingml/2006/main"/>
-          <a:lstStyle xmlns:a="http://schemas.openxmlformats.org/drawingml/2006/main"/>
-          <a:p xmlns:a="http://schemas.openxmlformats.org/drawingml/2006/main"/>
-        </p:txBody>
-      </p:sp>
-    </p:spTree>
-  </p:cSld>
-  <p:clrMapOvr>
-    <a:masterClrMapping xmlns:a="http://schemas.openxmlformats.org/drawingml/2006/main"/>
-  </p:clrMapOvr>
-</p:notes>
-</file>
-
-<file path=ppt/notesSlides/notesSlide5.xml><?xml version="1.0" encoding="utf-8"?>
-<p:notes xmlns:p="http://schemas.openxmlformats.org/presentationml/2006/main">
-  <p:cSld>
-    <p:spTree>
-      <p:nvGrpSpPr>
-        <p:cNvPr id="1" name=""/>
-        <p:cNvGrpSpPr/>
-        <p:nvPr/>
-      </p:nvGrpSpPr>
-      <p:grpSpPr>
-        <a:xfrm xmlns:a="http://schemas.openxmlformats.org/drawingml/2006/main"/>
-      </p:grpSpPr>
-      <p:sp>
-        <p:nvSpPr>
-          <p:cNvPr id="2" name="Slide Image Placeholder 1"/>
-          <p:cNvSpPr>
-            <a:spLocks xmlns:a="http://schemas.openxmlformats.org/drawingml/2006/main" noGrp="1"/>
-          </p:cNvSpPr>
-          <p:nvPr>
-            <p:ph type="sldImg" idx="0"/>
-          </p:nvPr>
-        </p:nvSpPr>
-        <p:spPr/>
-      </p:sp>
-      <p:sp>
-        <p:nvSpPr>
-          <p:cNvPr id="3" name="Notes Placeholder 2"/>
-          <p:cNvSpPr>
-            <a:spLocks xmlns:a="http://schemas.openxmlformats.org/drawingml/2006/main" noGrp="1"/>
-          </p:cNvSpPr>
-          <p:nvPr>
-            <p:ph type="body" idx="1"/>
-          </p:nvPr>
-        </p:nvSpPr>
-        <p:spPr/>
-        <p:txBody>
-          <a:bodyPr xmlns:a="http://schemas.openxmlformats.org/drawingml/2006/main"/>
-          <a:lstStyle xmlns:a="http://schemas.openxmlformats.org/drawingml/2006/main"/>
-          <a:p xmlns:a="http://schemas.openxmlformats.org/drawingml/2006/main">
-            <a:r>
-              <a:t>練習題來自 exercises.md 第 1 堂概念題 Q1。</a:t>
-            </a:r>
-          </a:p>
-        </p:txBody>
-      </p:sp>
-      <p:sp>
-        <p:nvSpPr>
-          <p:cNvPr id="4" name="Slide Number Placeholder 3"/>
-          <p:cNvSpPr>
-            <a:spLocks xmlns:a="http://schemas.openxmlformats.org/drawingml/2006/main" noGrp="1"/>
-          </p:cNvSpPr>
-          <p:nvPr>
-            <p:ph type="sldNum" idx="5"/>
-          </p:nvPr>
-        </p:nvSpPr>
-        <p:spPr/>
-        <p:txBody>
-          <a:bodyPr xmlns:a="http://schemas.openxmlformats.org/drawingml/2006/main"/>
-          <a:lstStyle xmlns:a="http://schemas.openxmlformats.org/drawingml/2006/main"/>
-          <a:p xmlns:a="http://schemas.openxmlformats.org/drawingml/2006/main"/>
-        </p:txBody>
-      </p:sp>
-    </p:spTree>
-  </p:cSld>
-  <p:clrMapOvr>
-    <a:masterClrMapping xmlns:a="http://schemas.openxmlformats.org/drawingml/2006/main"/>
-  </p:clrMapOvr>
-</p:notes>
-</file>
-
-<file path=ppt/notesSlides/notesSlide6.xml><?xml version="1.0" encoding="utf-8"?>
-<p:notes xmlns:p="http://schemas.openxmlformats.org/presentationml/2006/main">
-  <p:cSld>
-    <p:spTree>
-      <p:nvGrpSpPr>
-        <p:cNvPr id="1" name=""/>
-        <p:cNvGrpSpPr/>
-        <p:nvPr/>
-      </p:nvGrpSpPr>
-      <p:grpSpPr>
-        <a:xfrm xmlns:a="http://schemas.openxmlformats.org/drawingml/2006/main"/>
-      </p:grpSpPr>
-      <p:sp>
-        <p:nvSpPr>
-          <p:cNvPr id="2" name="Slide Image Placeholder 1"/>
-          <p:cNvSpPr>
-            <a:spLocks xmlns:a="http://schemas.openxmlformats.org/drawingml/2006/main" noGrp="1"/>
-          </p:cNvSpPr>
-          <p:nvPr>
-            <p:ph type="sldImg" idx="0"/>
-          </p:nvPr>
-        </p:nvSpPr>
-        <p:spPr/>
-      </p:sp>
-      <p:sp>
-        <p:nvSpPr>
-          <p:cNvPr id="3" name="Notes Placeholder 2"/>
-          <p:cNvSpPr>
-            <a:spLocks xmlns:a="http://schemas.openxmlformats.org/drawingml/2006/main" noGrp="1"/>
-          </p:cNvSpPr>
-          <p:nvPr>
-            <p:ph type="body" idx="1"/>
-          </p:nvPr>
-        </p:nvSpPr>
-        <p:spPr/>
-        <p:txBody>
-          <a:bodyPr xmlns:a="http://schemas.openxmlformats.org/drawingml/2006/main"/>
-          <a:lstStyle xmlns:a="http://schemas.openxmlformats.org/drawingml/2006/main"/>
-          <a:p xmlns:a="http://schemas.openxmlformats.org/drawingml/2006/main">
-            <a:r>
-              <a:t>這頁很適合補充 Apple Silicon 的案例。講義的目標學生使用 Windows，因此課堂上不會是主要問題，但實務上一定要知道。</a:t>
-            </a:r>
-          </a:p>
-        </p:txBody>
-      </p:sp>
-      <p:sp>
-        <p:nvSpPr>
-          <p:cNvPr id="4" name="Slide Number Placeholder 3"/>
-          <p:cNvSpPr>
-            <a:spLocks xmlns:a="http://schemas.openxmlformats.org/drawingml/2006/main" noGrp="1"/>
-          </p:cNvSpPr>
-          <p:nvPr>
-            <p:ph type="sldNum" idx="5"/>
-          </p:nvPr>
-        </p:nvSpPr>
-        <p:spPr/>
-        <p:txBody>
-          <a:bodyPr xmlns:a="http://schemas.openxmlformats.org/drawingml/2006/main"/>
-          <a:lstStyle xmlns:a="http://schemas.openxmlformats.org/drawingml/2006/main"/>
-          <a:p xmlns:a="http://schemas.openxmlformats.org/drawingml/2006/main"/>
-        </p:txBody>
-      </p:sp>
-    </p:spTree>
-  </p:cSld>
-  <p:clrMapOvr>
-    <a:masterClrMapping xmlns:a="http://schemas.openxmlformats.org/drawingml/2006/main"/>
-  </p:clrMapOvr>
-</p:notes>
-</file>
-
-<file path=ppt/notesSlides/notesSlide7.xml><?xml version="1.0" encoding="utf-8"?>
-<p:notes xmlns:p="http://schemas.openxmlformats.org/presentationml/2006/main">
-  <p:cSld>
-    <p:spTree>
-      <p:nvGrpSpPr>
-        <p:cNvPr id="1" name=""/>
-        <p:cNvGrpSpPr/>
-        <p:nvPr/>
-      </p:nvGrpSpPr>
-      <p:grpSpPr>
-        <a:xfrm xmlns:a="http://schemas.openxmlformats.org/drawingml/2006/main"/>
-      </p:grpSpPr>
-      <p:sp>
-        <p:nvSpPr>
-          <p:cNvPr id="2" name="Slide Image Placeholder 1"/>
-          <p:cNvSpPr>
-            <a:spLocks xmlns:a="http://schemas.openxmlformats.org/drawingml/2006/main" noGrp="1"/>
-          </p:cNvSpPr>
-          <p:nvPr>
-            <p:ph type="sldImg" idx="0"/>
-          </p:nvPr>
-        </p:nvSpPr>
-        <p:spPr/>
-      </p:sp>
-      <p:sp>
-        <p:nvSpPr>
-          <p:cNvPr id="3" name="Notes Placeholder 2"/>
-          <p:cNvSpPr>
-            <a:spLocks xmlns:a="http://schemas.openxmlformats.org/drawingml/2006/main" noGrp="1"/>
-          </p:cNvSpPr>
-          <p:nvPr>
-            <p:ph type="body" idx="1"/>
-          </p:nvPr>
-        </p:nvSpPr>
-        <p:spPr/>
-        <p:txBody>
-          <a:bodyPr xmlns:a="http://schemas.openxmlformats.org/drawingml/2006/main"/>
-          <a:lstStyle xmlns:a="http://schemas.openxmlformats.org/drawingml/2006/main"/>
-          <a:p xmlns:a="http://schemas.openxmlformats.org/drawingml/2006/main">
-            <a:r>
-              <a:t>練習題來自 exercises.md 第 1 堂概念題 Q3。答案是 B。</a:t>
-            </a:r>
-          </a:p>
-        </p:txBody>
-      </p:sp>
-      <p:sp>
-        <p:nvSpPr>
-          <p:cNvPr id="4" name="Slide Number Placeholder 3"/>
-          <p:cNvSpPr>
-            <a:spLocks xmlns:a="http://schemas.openxmlformats.org/drawingml/2006/main" noGrp="1"/>
-          </p:cNvSpPr>
-          <p:nvPr>
-            <p:ph type="sldNum" idx="5"/>
-          </p:nvPr>
-        </p:nvSpPr>
-        <p:spPr/>
-        <p:txBody>
-          <a:bodyPr xmlns:a="http://schemas.openxmlformats.org/drawingml/2006/main"/>
-          <a:lstStyle xmlns:a="http://schemas.openxmlformats.org/drawingml/2006/main"/>
-          <a:p xmlns:a="http://schemas.openxmlformats.org/drawingml/2006/main"/>
-        </p:txBody>
-      </p:sp>
-    </p:spTree>
-  </p:cSld>
-  <p:clrMapOvr>
-    <a:masterClrMapping xmlns:a="http://schemas.openxmlformats.org/drawingml/2006/main"/>
-  </p:clrMapOvr>
-</p:notes>
-</file>
-
-<file path=ppt/notesSlides/notesSlide8.xml><?xml version="1.0" encoding="utf-8"?>
-<p:notes xmlns:p="http://schemas.openxmlformats.org/presentationml/2006/main">
-  <p:cSld>
-    <p:spTree>
-      <p:nvGrpSpPr>
-        <p:cNvPr id="1" name=""/>
-        <p:cNvGrpSpPr/>
-        <p:nvPr/>
-      </p:nvGrpSpPr>
-      <p:grpSpPr>
-        <a:xfrm xmlns:a="http://schemas.openxmlformats.org/drawingml/2006/main"/>
-      </p:grpSpPr>
-      <p:sp>
-        <p:nvSpPr>
-          <p:cNvPr id="2" name="Slide Image Placeholder 1"/>
-          <p:cNvSpPr>
-            <a:spLocks xmlns:a="http://schemas.openxmlformats.org/drawingml/2006/main" noGrp="1"/>
-          </p:cNvSpPr>
-          <p:nvPr>
-            <p:ph type="sldImg" idx="0"/>
-          </p:nvPr>
-        </p:nvSpPr>
-        <p:spPr/>
-      </p:sp>
-      <p:sp>
-        <p:nvSpPr>
-          <p:cNvPr id="3" name="Notes Placeholder 2"/>
-          <p:cNvSpPr>
-            <a:spLocks xmlns:a="http://schemas.openxmlformats.org/drawingml/2006/main" noGrp="1"/>
-          </p:cNvSpPr>
-          <p:nvPr>
-            <p:ph type="body" idx="1"/>
-          </p:nvPr>
-        </p:nvSpPr>
-        <p:spPr/>
-        <p:txBody>
-          <a:bodyPr xmlns:a="http://schemas.openxmlformats.org/drawingml/2006/main"/>
-          <a:lstStyle xmlns:a="http://schemas.openxmlformats.org/drawingml/2006/main"/>
-          <a:p xmlns:a="http://schemas.openxmlformats.org/drawingml/2006/main">
-            <a:r>
-              <a:t>避免把 Docker 講成銀彈。這頁是建立工程判斷：Docker 優點大，但使用時要知道代價。</a:t>
-            </a:r>
-          </a:p>
-        </p:txBody>
-      </p:sp>
-      <p:sp>
-        <p:nvSpPr>
-          <p:cNvPr id="4" name="Slide Number Placeholder 3"/>
-          <p:cNvSpPr>
-            <a:spLocks xmlns:a="http://schemas.openxmlformats.org/drawingml/2006/main" noGrp="1"/>
-          </p:cNvSpPr>
-          <p:nvPr>
-            <p:ph type="sldNum" idx="5"/>
-          </p:nvPr>
-        </p:nvSpPr>
-        <p:spPr/>
-        <p:txBody>
-          <a:bodyPr xmlns:a="http://schemas.openxmlformats.org/drawingml/2006/main"/>
-          <a:lstStyle xmlns:a="http://schemas.openxmlformats.org/drawingml/2006/main"/>
-          <a:p xmlns:a="http://schemas.openxmlformats.org/drawingml/2006/main"/>
-        </p:txBody>
-      </p:sp>
-    </p:spTree>
-  </p:cSld>
-  <p:clrMapOvr>
-    <a:masterClrMapping xmlns:a="http://schemas.openxmlformats.org/drawingml/2006/main"/>
-  </p:clrMapOvr>
-</p:notes>
-</file>
-
-<file path=ppt/notesSlides/notesSlide9.xml><?xml version="1.0" encoding="utf-8"?>
-<p:notes xmlns:p="http://schemas.openxmlformats.org/presentationml/2006/main">
-  <p:cSld>
-    <p:spTree>
-      <p:nvGrpSpPr>
-        <p:cNvPr id="1" name=""/>
-        <p:cNvGrpSpPr/>
-        <p:nvPr/>
-      </p:nvGrpSpPr>
-      <p:grpSpPr>
-        <a:xfrm xmlns:a="http://schemas.openxmlformats.org/drawingml/2006/main"/>
-      </p:grpSpPr>
-      <p:sp>
-        <p:nvSpPr>
-          <p:cNvPr id="2" name="Slide Image Placeholder 1"/>
-          <p:cNvSpPr>
-            <a:spLocks xmlns:a="http://schemas.openxmlformats.org/drawingml/2006/main" noGrp="1"/>
-          </p:cNvSpPr>
-          <p:nvPr>
-            <p:ph type="sldImg" idx="0"/>
-          </p:nvPr>
-        </p:nvSpPr>
-        <p:spPr/>
-      </p:sp>
-      <p:sp>
-        <p:nvSpPr>
-          <p:cNvPr id="3" name="Notes Placeholder 2"/>
-          <p:cNvSpPr>
-            <a:spLocks xmlns:a="http://schemas.openxmlformats.org/drawingml/2006/main" noGrp="1"/>
-          </p:cNvSpPr>
-          <p:nvPr>
-            <p:ph type="body" idx="1"/>
-          </p:nvPr>
-        </p:nvSpPr>
-        <p:spPr/>
-        <p:txBody>
-          <a:bodyPr xmlns:a="http://schemas.openxmlformats.org/drawingml/2006/main"/>
-          <a:lstStyle xmlns:a="http://schemas.openxmlformats.org/drawingml/2006/main"/>
-          <a:p xmlns:a="http://schemas.openxmlformats.org/drawingml/2006/main">
-            <a:r>
-              <a:t>這是後面所有指令的核心模型。docker pull 對 Image，docker run 產生 Container。</a:t>
-            </a:r>
-          </a:p>
-        </p:txBody>
-      </p:sp>
-      <p:sp>
-        <p:nvSpPr>
-          <p:cNvPr id="4" name="Slide Number Placeholder 3"/>
-          <p:cNvSpPr>
-            <a:spLocks xmlns:a="http://schemas.openxmlformats.org/drawingml/2006/main" noGrp="1"/>
-          </p:cNvSpPr>
-          <p:nvPr>
-            <p:ph type="sldNum" idx="5"/>
-          </p:nvPr>
-        </p:nvSpPr>
-        <p:spPr/>
-        <p:txBody>
-          <a:bodyPr xmlns:a="http://schemas.openxmlformats.org/drawingml/2006/main"/>
-          <a:lstStyle xmlns:a="http://schemas.openxmlformats.org/drawingml/2006/main"/>
-          <a:p xmlns:a="http://schemas.openxmlformats.org/drawingml/2006/main"/>
-        </p:txBody>
-      </p:sp>
-    </p:spTree>
-  </p:cSld>
-  <p:clrMapOvr>
-    <a:masterClrMapping xmlns:a="http://schemas.openxmlformats.org/drawingml/2006/main"/>
-  </p:clrMapOvr>
-</p:notes>
-</file>
-
 <file path=ppt/slideLayouts/slideLayout1.xml><?xml version="1.0" encoding="utf-8"?>
 <p:sldLayout xmlns:p="http://schemas.openxmlformats.org/presentationml/2006/main" type="title">
   <p:cSld name="Title Slide">
@@ -2451,7 +171,7 @@
   </p:cSld>
   <p:clrMap bg1="lt1" tx1="dk1" bg2="lt2" tx2="dk2" accent1="accent1" accent2="accent2" accent3="accent3" accent4="accent4" accent5="accent5" accent6="accent6" hlink="hlink" folHlink="folHlink"/>
   <p:sldLayoutIdLst>
-    <p:sldLayoutId xmlns:r="http://schemas.openxmlformats.org/officeDocument/2006/relationships" id="2147483649" r:id="Re56b90e3d4544c57"/>
+    <p:sldLayoutId xmlns:r="http://schemas.openxmlformats.org/officeDocument/2006/relationships" id="2147483649" r:id="R18d424fa0a364d7e"/>
   </p:sldLayoutIdLst>
   <p:txStyles>
     <p:titleStyle>
@@ -3041,14 +761,14 @@
       </p:sp>
       <p:pic>
         <p:nvPicPr>
-          <p:cNvPr id="14" name=""/>
+          <p:cNvPr id="15" name=""/>
           <p:cNvPicPr>
             <a:picLocks xmlns:a="http://schemas.openxmlformats.org/drawingml/2006/main" noChangeAspect="1"/>
           </p:cNvPicPr>
           <p:nvPr/>
         </p:nvPicPr>
         <p:blipFill>
-          <a:blip xmlns:r="http://schemas.openxmlformats.org/officeDocument/2006/relationships" xmlns:a="http://schemas.openxmlformats.org/drawingml/2006/main" r:embed="R12c4a6b3dbc845f2"/>
+          <a:blip xmlns:r="http://schemas.openxmlformats.org/officeDocument/2006/relationships" xmlns:a="http://schemas.openxmlformats.org/drawingml/2006/main" r:embed="R825bada15ef54c72"/>
           <a:srcRect xmlns:a="http://schemas.openxmlformats.org/drawingml/2006/main" l="20297" t="0" r="20297" b="0"/>
           <a:stretch xmlns:a="http://schemas.openxmlformats.org/drawingml/2006/main">
             <a:fillRect l="0" t="0" r="0" b="0"/>
@@ -34238,14 +31958,14 @@
       </p:sp>
       <p:pic>
         <p:nvPicPr>
-          <p:cNvPr id="22" name=""/>
+          <p:cNvPr id="23" name=""/>
           <p:cNvPicPr>
             <a:picLocks xmlns:a="http://schemas.openxmlformats.org/drawingml/2006/main" noChangeAspect="1"/>
           </p:cNvPicPr>
           <p:nvPr/>
         </p:nvPicPr>
         <p:blipFill>
-          <a:blip xmlns:r="http://schemas.openxmlformats.org/officeDocument/2006/relationships" xmlns:a="http://schemas.openxmlformats.org/drawingml/2006/main" r:embed="Raa8b74676f6740c9"/>
+          <a:blip xmlns:r="http://schemas.openxmlformats.org/officeDocument/2006/relationships" xmlns:a="http://schemas.openxmlformats.org/drawingml/2006/main" r:embed="R678addf24761433b"/>
           <a:srcRect xmlns:a="http://schemas.openxmlformats.org/drawingml/2006/main" l="106" t="0" r="106" b="0"/>
           <a:stretch xmlns:a="http://schemas.openxmlformats.org/drawingml/2006/main">
             <a:fillRect l="0" t="0" r="0" b="0"/>
@@ -34257,9 +31977,7 @@
             <a:ext cx="4762500" cy="2686050"/>
           </a:xfrm>
           <a:prstGeom xmlns:a="http://schemas.openxmlformats.org/drawingml/2006/main" prst="roundRect">
-            <a:avLst>
-              <a:gd name="adj" fmla="val 4965"/>
-            </a:avLst>
+            <a:avLst/>
           </a:prstGeom>
         </p:spPr>
       </p:pic>

</xml_diff>

<commit_message>
Interleave slide code examples
</commit_message>
<xml_diff>
--- a/slides/docker-session1-basics-setup.pptx
+++ b/slides/docker-session1-basics-setup.pptx
@@ -30,15 +30,15 @@
     <p:sldId xmlns:r="http://schemas.openxmlformats.org/officeDocument/2006/relationships" id="275" r:id="Re7909a35720f4790"/>
     <p:sldId xmlns:r="http://schemas.openxmlformats.org/officeDocument/2006/relationships" id="276" r:id="Rad7faa5a408b4e58"/>
     <p:sldId xmlns:r="http://schemas.openxmlformats.org/officeDocument/2006/relationships" id="277" r:id="R48e424fea76c4627"/>
+    <p:sldId id="283" r:id="rId1"/>
     <p:sldId xmlns:r="http://schemas.openxmlformats.org/officeDocument/2006/relationships" id="278" r:id="Rf14069a11143499b"/>
     <p:sldId xmlns:r="http://schemas.openxmlformats.org/officeDocument/2006/relationships" id="279" r:id="R8c2bfe1ccc954101"/>
+    <p:sldId id="284" r:id="rId2"/>
+    <p:sldId id="285" r:id="rId3"/>
     <p:sldId xmlns:r="http://schemas.openxmlformats.org/officeDocument/2006/relationships" id="280" r:id="R8b3293098fd74ef5"/>
     <p:sldId xmlns:r="http://schemas.openxmlformats.org/officeDocument/2006/relationships" id="281" r:id="Reb2a6ab6c203454b"/>
+    <p:sldId id="286" r:id="rId4"/>
     <p:sldId xmlns:r="http://schemas.openxmlformats.org/officeDocument/2006/relationships" id="282" r:id="Rbd1f54cec190419b"/>
-    <p:sldId id="283" r:id="rId1"/>
-    <p:sldId id="284" r:id="rId2"/>
-    <p:sldId id="285" r:id="rId3"/>
-    <p:sldId id="286" r:id="rId4"/>
   </p:sldIdLst>
   <p:sldSz cx="12192000" cy="6858000"/>
   <p:notesSz cx="6858000" cy="9144000"/>
@@ -24743,7 +24743,7 @@
 
 <file path=ppt/slides/slide28.xml><?xml version="1.0" encoding="utf-8"?>
 <p:sld xmlns:a="http://schemas.openxmlformats.org/drawingml/2006/main" xmlns:r="http://schemas.openxmlformats.org/officeDocument/2006/relationships" xmlns:p="http://schemas.openxmlformats.org/presentationml/2006/main">
-  <p:cSld name="程式碼附錄 1: Nginx 起手式">
+  <p:cSld name="範例程式碼：Nginx 起手式">
     <p:bg>
       <p:bgPr>
         <a:solidFill>
@@ -24800,7 +24800,7 @@
                 <a:ea typeface="Aptos"/>
                 <a:cs typeface="Aptos"/>
               </a:rPr>
-              <a:t>CODE APPENDIX</a:t>
+              <a:t>CODE EXAMPLE</a:t>
             </a:r>
           </a:p>
         </p:txBody>
@@ -24839,7 +24839,7 @@
                 <a:ea typeface="Aptos"/>
                 <a:cs typeface="Aptos"/>
               </a:rPr>
-              <a:t>程式碼附錄 1: Nginx 起手式</a:t>
+              <a:t>範例程式碼：Nginx 起手式</a:t>
             </a:r>
           </a:p>
         </p:txBody>
@@ -25064,7 +25064,7 @@
                 <a:ea typeface="Aptos"/>
                 <a:cs typeface="Aptos"/>
               </a:rPr>
-              <a:t>Docker 基礎教學 | 第 1 堂 | Code 1/4</a:t>
+              <a:t>Docker 基礎教學 | 第 1 堂 | 範例程式碼</a:t>
             </a:r>
           </a:p>
         </p:txBody>
@@ -25103,7 +25103,7 @@
                 <a:ea typeface="Aptos"/>
                 <a:cs typeface="Aptos"/>
               </a:rPr>
-              <a:t>A1</a:t>
+              <a:t>CODE</a:t>
             </a:r>
           </a:p>
         </p:txBody>
@@ -25118,7 +25118,7 @@
 
 <file path=ppt/slides/slide29.xml><?xml version="1.0" encoding="utf-8"?>
 <p:sld xmlns:a="http://schemas.openxmlformats.org/drawingml/2006/main" xmlns:r="http://schemas.openxmlformats.org/officeDocument/2006/relationships" xmlns:p="http://schemas.openxmlformats.org/presentationml/2006/main">
-  <p:cSld name="程式碼附錄 2: 進入 Nginx 容器檢查 (1/2)">
+  <p:cSld name="範例程式碼：進入 Nginx 容器檢查 (1/2)">
     <p:bg>
       <p:bgPr>
         <a:solidFill>
@@ -25175,7 +25175,7 @@
                 <a:ea typeface="Aptos"/>
                 <a:cs typeface="Aptos"/>
               </a:rPr>
-              <a:t>CODE APPENDIX</a:t>
+              <a:t>CODE EXAMPLE</a:t>
             </a:r>
           </a:p>
         </p:txBody>
@@ -25214,7 +25214,7 @@
                 <a:ea typeface="Aptos"/>
                 <a:cs typeface="Aptos"/>
               </a:rPr>
-              <a:t>程式碼附錄 2: 進入 Nginx 容器檢查 (1/2)</a:t>
+              <a:t>範例程式碼：進入 Nginx 容器檢查 (1/2)</a:t>
             </a:r>
           </a:p>
         </p:txBody>
@@ -25647,7 +25647,7 @@
                 <a:ea typeface="Aptos"/>
                 <a:cs typeface="Aptos"/>
               </a:rPr>
-              <a:t>Docker 基礎教學 | 第 1 堂 | Code 2/4</a:t>
+              <a:t>Docker 基礎教學 | 第 1 堂 | 範例程式碼</a:t>
             </a:r>
           </a:p>
         </p:txBody>
@@ -25686,7 +25686,7 @@
                 <a:ea typeface="Aptos"/>
                 <a:cs typeface="Aptos"/>
               </a:rPr>
-              <a:t>A2</a:t>
+              <a:t>CODE</a:t>
             </a:r>
           </a:p>
         </p:txBody>
@@ -27049,7 +27049,7 @@
 
 <file path=ppt/slides/slide30.xml><?xml version="1.0" encoding="utf-8"?>
 <p:sld xmlns:a="http://schemas.openxmlformats.org/drawingml/2006/main" xmlns:r="http://schemas.openxmlformats.org/officeDocument/2006/relationships" xmlns:p="http://schemas.openxmlformats.org/presentationml/2006/main">
-  <p:cSld name="程式碼附錄 3: 進入 Nginx 容器檢查 (2/2)">
+  <p:cSld name="範例程式碼：進入 Nginx 容器檢查 (2/2)">
     <p:bg>
       <p:bgPr>
         <a:solidFill>
@@ -27106,7 +27106,7 @@
                 <a:ea typeface="Aptos"/>
                 <a:cs typeface="Aptos"/>
               </a:rPr>
-              <a:t>CODE APPENDIX</a:t>
+              <a:t>CODE EXAMPLE</a:t>
             </a:r>
           </a:p>
         </p:txBody>
@@ -27145,7 +27145,7 @@
                 <a:ea typeface="Aptos"/>
                 <a:cs typeface="Aptos"/>
               </a:rPr>
-              <a:t>程式碼附錄 3: 進入 Nginx 容器檢查 (2/2)</a:t>
+              <a:t>範例程式碼：進入 Nginx 容器檢查 (2/2)</a:t>
             </a:r>
           </a:p>
         </p:txBody>
@@ -27318,7 +27318,7 @@
                 <a:ea typeface="Aptos"/>
                 <a:cs typeface="Aptos"/>
               </a:rPr>
-              <a:t>Docker 基礎教學 | 第 1 堂 | Code 3/4</a:t>
+              <a:t>Docker 基礎教學 | 第 1 堂 | 範例程式碼</a:t>
             </a:r>
           </a:p>
         </p:txBody>
@@ -27357,7 +27357,7 @@
                 <a:ea typeface="Aptos"/>
                 <a:cs typeface="Aptos"/>
               </a:rPr>
-              <a:t>A3</a:t>
+              <a:t>CODE</a:t>
             </a:r>
           </a:p>
         </p:txBody>
@@ -27372,7 +27372,7 @@
 
 <file path=ppt/slides/slide31.xml><?xml version="1.0" encoding="utf-8"?>
 <p:sld xmlns:a="http://schemas.openxmlformats.org/drawingml/2006/main" xmlns:r="http://schemas.openxmlformats.org/officeDocument/2006/relationships" xmlns:p="http://schemas.openxmlformats.org/presentationml/2006/main">
-  <p:cSld name="程式碼附錄 4: 狀態查看與清理">
+  <p:cSld name="範例程式碼：狀態查看與清理">
     <p:bg>
       <p:bgPr>
         <a:solidFill>
@@ -27429,7 +27429,7 @@
                 <a:ea typeface="Aptos"/>
                 <a:cs typeface="Aptos"/>
               </a:rPr>
-              <a:t>CODE APPENDIX</a:t>
+              <a:t>CODE EXAMPLE</a:t>
             </a:r>
           </a:p>
         </p:txBody>
@@ -27468,7 +27468,7 @@
                 <a:ea typeface="Aptos"/>
                 <a:cs typeface="Aptos"/>
               </a:rPr>
-              <a:t>程式碼附錄 4: 狀態查看與清理</a:t>
+              <a:t>範例程式碼：狀態查看與清理</a:t>
             </a:r>
           </a:p>
         </p:txBody>
@@ -27797,7 +27797,7 @@
                 <a:ea typeface="Aptos"/>
                 <a:cs typeface="Aptos"/>
               </a:rPr>
-              <a:t>Docker 基礎教學 | 第 1 堂 | Code 4/4</a:t>
+              <a:t>Docker 基礎教學 | 第 1 堂 | 範例程式碼</a:t>
             </a:r>
           </a:p>
         </p:txBody>
@@ -27836,7 +27836,7 @@
                 <a:ea typeface="Aptos"/>
                 <a:cs typeface="Aptos"/>
               </a:rPr>
-              <a:t>A4</a:t>
+              <a:t>CODE</a:t>
             </a:r>
           </a:p>
         </p:txBody>

</xml_diff>

<commit_message>
Fix Docker slide PPTX structure
</commit_message>
<xml_diff>
--- a/slides/docker-session1-basics-setup.pptx
+++ b/slides/docker-session1-basics-setup.pptx
@@ -1,52 +1,49 @@
 
 <file path=ppt/presentation.xml><?xml version="1.0" encoding="utf-8"?>
-<p:presentation xmlns:p="http://schemas.openxmlformats.org/presentationml/2006/main" xmlns:r="http://schemas.openxmlformats.org/officeDocument/2006/relationships">
+<p:presentation xmlns:a="http://schemas.openxmlformats.org/drawingml/2006/main" xmlns:p="http://schemas.openxmlformats.org/presentationml/2006/main" xmlns:r="http://schemas.openxmlformats.org/officeDocument/2006/relationships">
   <p:sldMasterIdLst>
-    <p:sldMasterId xmlns:r="http://schemas.openxmlformats.org/officeDocument/2006/relationships" id="2147483648" r:id="R9d95461ccd5a435d"/>
+    <p:sldMasterId id="2147483648" r:id="R9d95461ccd5a435d"/>
   </p:sldMasterIdLst>
-  <p:notesMasterIdLst>
-    <p:notesMasterId xmlns:r="http://schemas.openxmlformats.org/officeDocument/2006/relationships" r:id="Re7c72efc286f43a9"/>
-  </p:notesMasterIdLst>
   <p:sldIdLst>
-    <p:sldId xmlns:r="http://schemas.openxmlformats.org/officeDocument/2006/relationships" id="256" r:id="R534a20be6a554624"/>
-    <p:sldId xmlns:r="http://schemas.openxmlformats.org/officeDocument/2006/relationships" id="257" r:id="R85c70f84879a4812"/>
-    <p:sldId xmlns:r="http://schemas.openxmlformats.org/officeDocument/2006/relationships" id="258" r:id="R7874a43df70e48cb"/>
-    <p:sldId xmlns:r="http://schemas.openxmlformats.org/officeDocument/2006/relationships" id="259" r:id="Re99b3704889f4d49"/>
-    <p:sldId xmlns:r="http://schemas.openxmlformats.org/officeDocument/2006/relationships" id="260" r:id="R3236acdfcab64870"/>
-    <p:sldId xmlns:r="http://schemas.openxmlformats.org/officeDocument/2006/relationships" id="261" r:id="R64bbdd81cd314281"/>
-    <p:sldId xmlns:r="http://schemas.openxmlformats.org/officeDocument/2006/relationships" id="262" r:id="R6d3793b2232145df"/>
-    <p:sldId xmlns:r="http://schemas.openxmlformats.org/officeDocument/2006/relationships" id="263" r:id="Rc0ae04078daa441c"/>
-    <p:sldId xmlns:r="http://schemas.openxmlformats.org/officeDocument/2006/relationships" id="264" r:id="R3a357448888548ed"/>
-    <p:sldId xmlns:r="http://schemas.openxmlformats.org/officeDocument/2006/relationships" id="265" r:id="Rc8b84611a13249ad"/>
-    <p:sldId xmlns:r="http://schemas.openxmlformats.org/officeDocument/2006/relationships" id="266" r:id="R13a519ccef9e4d67"/>
-    <p:sldId xmlns:r="http://schemas.openxmlformats.org/officeDocument/2006/relationships" id="267" r:id="Rfab575397dc2490f"/>
-    <p:sldId xmlns:r="http://schemas.openxmlformats.org/officeDocument/2006/relationships" id="268" r:id="R41cb82ad261f454c"/>
-    <p:sldId xmlns:r="http://schemas.openxmlformats.org/officeDocument/2006/relationships" id="269" r:id="R51dc3817afe045b5"/>
-    <p:sldId xmlns:r="http://schemas.openxmlformats.org/officeDocument/2006/relationships" id="270" r:id="Re8af338f0f9e4a6d"/>
-    <p:sldId xmlns:r="http://schemas.openxmlformats.org/officeDocument/2006/relationships" id="271" r:id="Rdb3f5a3796534bd7"/>
-    <p:sldId xmlns:r="http://schemas.openxmlformats.org/officeDocument/2006/relationships" id="272" r:id="R6ee63b6ecda0406c"/>
-    <p:sldId xmlns:r="http://schemas.openxmlformats.org/officeDocument/2006/relationships" id="273" r:id="R32181bae7ddf4814"/>
-    <p:sldId xmlns:r="http://schemas.openxmlformats.org/officeDocument/2006/relationships" id="274" r:id="R280fb19bbba24d46"/>
-    <p:sldId xmlns:r="http://schemas.openxmlformats.org/officeDocument/2006/relationships" id="275" r:id="Re7909a35720f4790"/>
-    <p:sldId xmlns:r="http://schemas.openxmlformats.org/officeDocument/2006/relationships" id="276" r:id="Rad7faa5a408b4e58"/>
-    <p:sldId xmlns:r="http://schemas.openxmlformats.org/officeDocument/2006/relationships" id="277" r:id="R48e424fea76c4627"/>
+    <p:sldId id="256" r:id="R534a20be6a554624"/>
+    <p:sldId id="257" r:id="R85c70f84879a4812"/>
+    <p:sldId id="258" r:id="R7874a43df70e48cb"/>
+    <p:sldId id="259" r:id="Re99b3704889f4d49"/>
+    <p:sldId id="260" r:id="R3236acdfcab64870"/>
+    <p:sldId id="261" r:id="R64bbdd81cd314281"/>
+    <p:sldId id="262" r:id="R6d3793b2232145df"/>
+    <p:sldId id="263" r:id="Rc0ae04078daa441c"/>
+    <p:sldId id="264" r:id="R3a357448888548ed"/>
+    <p:sldId id="265" r:id="Rc8b84611a13249ad"/>
+    <p:sldId id="266" r:id="R13a519ccef9e4d67"/>
+    <p:sldId id="267" r:id="Rfab575397dc2490f"/>
+    <p:sldId id="268" r:id="R41cb82ad261f454c"/>
+    <p:sldId id="269" r:id="R51dc3817afe045b5"/>
+    <p:sldId id="270" r:id="Re8af338f0f9e4a6d"/>
+    <p:sldId id="271" r:id="Rdb3f5a3796534bd7"/>
+    <p:sldId id="272" r:id="R6ee63b6ecda0406c"/>
+    <p:sldId id="273" r:id="R32181bae7ddf4814"/>
+    <p:sldId id="274" r:id="R280fb19bbba24d46"/>
+    <p:sldId id="275" r:id="Re7909a35720f4790"/>
+    <p:sldId id="276" r:id="Rad7faa5a408b4e58"/>
+    <p:sldId id="277" r:id="R48e424fea76c4627"/>
     <p:sldId id="283" r:id="rId1"/>
-    <p:sldId xmlns:r="http://schemas.openxmlformats.org/officeDocument/2006/relationships" id="278" r:id="Rf14069a11143499b"/>
-    <p:sldId xmlns:r="http://schemas.openxmlformats.org/officeDocument/2006/relationships" id="279" r:id="R8c2bfe1ccc954101"/>
+    <p:sldId id="278" r:id="Rf14069a11143499b"/>
+    <p:sldId id="279" r:id="R8c2bfe1ccc954101"/>
     <p:sldId id="284" r:id="rId2"/>
     <p:sldId id="285" r:id="rId3"/>
-    <p:sldId xmlns:r="http://schemas.openxmlformats.org/officeDocument/2006/relationships" id="280" r:id="R8b3293098fd74ef5"/>
-    <p:sldId xmlns:r="http://schemas.openxmlformats.org/officeDocument/2006/relationships" id="281" r:id="Reb2a6ab6c203454b"/>
+    <p:sldId id="280" r:id="R8b3293098fd74ef5"/>
+    <p:sldId id="281" r:id="Reb2a6ab6c203454b"/>
     <p:sldId id="286" r:id="rId4"/>
-    <p:sldId xmlns:r="http://schemas.openxmlformats.org/officeDocument/2006/relationships" id="282" r:id="Rbd1f54cec190419b"/>
+    <p:sldId id="282" r:id="Rbd1f54cec190419b"/>
   </p:sldIdLst>
   <p:sldSz cx="12192000" cy="6858000"/>
   <p:notesSz cx="6858000" cy="9144000"/>
   <p:defaultTextStyle>
-    <a:defPPr xmlns:a="http://schemas.openxmlformats.org/drawingml/2006/main">
+    <a:defPPr>
       <a:defRPr lang="en-US"/>
     </a:defPPr>
-    <a:lvl1pPr xmlns:a="http://schemas.openxmlformats.org/drawingml/2006/main" marL="0" indent="0" algn="l" defTabSz="914400">
+    <a:lvl1pPr marL="0" indent="0" algn="l" defTabSz="914400">
       <a:defRPr sz="1800" kern="1200">
         <a:solidFill>
           <a:schemeClr val="tx1"/>
@@ -56,7 +53,7 @@
         <a:cs typeface="+mn-cs"/>
       </a:defRPr>
     </a:lvl1pPr>
-    <a:lvl2pPr xmlns:a="http://schemas.openxmlformats.org/drawingml/2006/main" marL="457200" indent="0" algn="l" defTabSz="914400">
+    <a:lvl2pPr marL="457200" indent="0" algn="l" defTabSz="914400">
       <a:defRPr sz="1800" kern="1200">
         <a:solidFill>
           <a:schemeClr val="tx1"/>
@@ -66,7 +63,7 @@
         <a:cs typeface="+mn-cs"/>
       </a:defRPr>
     </a:lvl2pPr>
-    <a:lvl3pPr xmlns:a="http://schemas.openxmlformats.org/drawingml/2006/main" marL="914400" indent="0" algn="l" defTabSz="914400">
+    <a:lvl3pPr marL="914400" indent="0" algn="l" defTabSz="914400">
       <a:defRPr sz="1800" kern="1200">
         <a:solidFill>
           <a:schemeClr val="tx1"/>
@@ -76,7 +73,7 @@
         <a:cs typeface="+mn-cs"/>
       </a:defRPr>
     </a:lvl3pPr>
-    <a:lvl4pPr xmlns:a="http://schemas.openxmlformats.org/drawingml/2006/main" marL="1371600" indent="0" algn="l" defTabSz="914400">
+    <a:lvl4pPr marL="1371600" indent="0" algn="l" defTabSz="914400">
       <a:defRPr sz="1800" kern="1200">
         <a:solidFill>
           <a:schemeClr val="tx1"/>
@@ -86,7 +83,7 @@
         <a:cs typeface="+mn-cs"/>
       </a:defRPr>
     </a:lvl4pPr>
-    <a:lvl5pPr xmlns:a="http://schemas.openxmlformats.org/drawingml/2006/main" marL="1828800" indent="0" algn="l" defTabSz="914400">
+    <a:lvl5pPr marL="1828800" indent="0" algn="l" defTabSz="914400">
       <a:defRPr sz="1800" kern="1200">
         <a:solidFill>
           <a:schemeClr val="tx1"/>
@@ -96,7 +93,7 @@
         <a:cs typeface="+mn-cs"/>
       </a:defRPr>
     </a:lvl5pPr>
-    <a:lvl6pPr xmlns:a="http://schemas.openxmlformats.org/drawingml/2006/main" marL="2286000" indent="0" algn="l" defTabSz="914400">
+    <a:lvl6pPr marL="2286000" indent="0" algn="l" defTabSz="914400">
       <a:defRPr sz="1800" kern="1200">
         <a:solidFill>
           <a:schemeClr val="tx1"/>
@@ -106,7 +103,7 @@
         <a:cs typeface="+mn-cs"/>
       </a:defRPr>
     </a:lvl6pPr>
-    <a:lvl7pPr xmlns:a="http://schemas.openxmlformats.org/drawingml/2006/main" marL="2743200" indent="0" algn="l" defTabSz="914400">
+    <a:lvl7pPr marL="2743200" indent="0" algn="l" defTabSz="914400">
       <a:defRPr sz="1800" kern="1200">
         <a:solidFill>
           <a:schemeClr val="tx1"/>
@@ -116,7 +113,7 @@
         <a:cs typeface="+mn-cs"/>
       </a:defRPr>
     </a:lvl7pPr>
-    <a:lvl8pPr xmlns:a="http://schemas.openxmlformats.org/drawingml/2006/main" marL="3200400" indent="0" algn="l" defTabSz="914400">
+    <a:lvl8pPr marL="3200400" indent="0" algn="l" defTabSz="914400">
       <a:defRPr sz="1800" kern="1200">
         <a:solidFill>
           <a:schemeClr val="tx1"/>
@@ -126,7 +123,7 @@
         <a:cs typeface="+mn-cs"/>
       </a:defRPr>
     </a:lvl8pPr>
-    <a:lvl9pPr xmlns:a="http://schemas.openxmlformats.org/drawingml/2006/main" marL="3657600" indent="0" algn="l" defTabSz="914400">
+    <a:lvl9pPr marL="3657600" indent="0" algn="l" defTabSz="914400">
       <a:defRPr sz="1800" kern="1200">
         <a:solidFill>
           <a:schemeClr val="tx1"/>
@@ -1632,8 +1629,8 @@
         </p:nvSpPr>
         <p:spPr>
           <a:xfrm>
-            <a:off x="1047750" y="2628900"/>
-            <a:ext cx="323850" cy="-190500"/>
+            <a:off x="1047750" y="2438400"/>
+            <a:ext cx="323850" cy="190500"/>
           </a:xfrm>
           <a:prstGeom prst="rect">
             <a:avLst/>
@@ -1775,8 +1772,8 @@
         </p:nvSpPr>
         <p:spPr>
           <a:xfrm>
-            <a:off x="1962150" y="2628900"/>
-            <a:ext cx="323850" cy="-190500"/>
+            <a:off x="1962150" y="2438400"/>
+            <a:ext cx="323850" cy="190500"/>
           </a:xfrm>
           <a:prstGeom prst="rect">
             <a:avLst/>
@@ -1918,8 +1915,8 @@
         </p:nvSpPr>
         <p:spPr>
           <a:xfrm>
-            <a:off x="2876550" y="2628900"/>
-            <a:ext cx="323850" cy="-190500"/>
+            <a:off x="2876550" y="2438400"/>
+            <a:ext cx="323850" cy="190500"/>
           </a:xfrm>
           <a:prstGeom prst="rect">
             <a:avLst/>
@@ -2061,8 +2058,8 @@
         </p:nvSpPr>
         <p:spPr>
           <a:xfrm>
-            <a:off x="1047750" y="3371850"/>
-            <a:ext cx="2171700" cy="-190500"/>
+            <a:off x="1047750" y="3181350"/>
+            <a:ext cx="2171700" cy="190500"/>
           </a:xfrm>
           <a:prstGeom prst="rect">
             <a:avLst/>
@@ -2204,8 +2201,8 @@
         </p:nvSpPr>
         <p:spPr>
           <a:xfrm>
-            <a:off x="1047750" y="4095750"/>
-            <a:ext cx="2171700" cy="-190500"/>
+            <a:off x="1047750" y="3905250"/>
+            <a:ext cx="2171700" cy="190500"/>
           </a:xfrm>
           <a:prstGeom prst="rect">
             <a:avLst/>
@@ -2347,8 +2344,8 @@
         </p:nvSpPr>
         <p:spPr>
           <a:xfrm>
-            <a:off x="1047750" y="4819650"/>
-            <a:ext cx="2171700" cy="-190500"/>
+            <a:off x="1047750" y="4629150"/>
+            <a:ext cx="2171700" cy="190500"/>
           </a:xfrm>
           <a:prstGeom prst="rect">
             <a:avLst/>
@@ -3095,8 +3092,8 @@
         </p:nvSpPr>
         <p:spPr>
           <a:xfrm>
-            <a:off x="4838700" y="4095750"/>
-            <a:ext cx="2019300" cy="-247650"/>
+            <a:off x="4838700" y="3848100"/>
+            <a:ext cx="2019300" cy="247650"/>
           </a:xfrm>
           <a:prstGeom prst="rect">
             <a:avLst/>
@@ -3238,8 +3235,8 @@
         </p:nvSpPr>
         <p:spPr>
           <a:xfrm>
-            <a:off x="4838700" y="4762500"/>
-            <a:ext cx="2019300" cy="-247650"/>
+            <a:off x="4838700" y="4514850"/>
+            <a:ext cx="2019300" cy="247650"/>
           </a:xfrm>
           <a:prstGeom prst="rect">
             <a:avLst/>
@@ -4097,8 +4094,8 @@
         </p:nvSpPr>
         <p:spPr>
           <a:xfrm>
-            <a:off x="8362950" y="3848100"/>
-            <a:ext cx="2228850" cy="-247650"/>
+            <a:off x="8362950" y="3600450"/>
+            <a:ext cx="2228850" cy="247650"/>
           </a:xfrm>
           <a:prstGeom prst="rect">
             <a:avLst/>
@@ -4240,8 +4237,8 @@
         </p:nvSpPr>
         <p:spPr>
           <a:xfrm>
-            <a:off x="8362950" y="4514850"/>
-            <a:ext cx="2228850" cy="-247650"/>
+            <a:off x="8362950" y="4267200"/>
+            <a:ext cx="2228850" cy="247650"/>
           </a:xfrm>
           <a:prstGeom prst="rect">
             <a:avLst/>
@@ -4383,8 +4380,8 @@
         </p:nvSpPr>
         <p:spPr>
           <a:xfrm>
-            <a:off x="8362950" y="5181600"/>
-            <a:ext cx="2228850" cy="-323850"/>
+            <a:off x="8362950" y="4857750"/>
+            <a:ext cx="2228850" cy="323850"/>
           </a:xfrm>
           <a:prstGeom prst="rect">
             <a:avLst/>

</xml_diff>

<commit_message>
Update session 1 slides
</commit_message>
<xml_diff>
--- a/slides/docker-session1-basics-setup.pptx
+++ b/slides/docker-session1-basics-setup.pptx
@@ -138,6 +138,11 @@
       </a:defRPr>
     </a:lvl9pPr>
   </p:defaultTextStyle>
+  <p:extLst>
+    <p:ext uri="{EFAFB233-063F-42B5-8137-9DF3F51BA10A}">
+      <p15:sldGuideLst xmlns:p15="http://schemas.microsoft.com/office/powerpoint/2012/main"/>
+    </p:ext>
+  </p:extLst>
 </p:presentation>
 </file>
 
@@ -6017,7 +6022,7 @@
         </p:spPr>
         <p:txBody>
           <a:bodyPr lIns="0" tIns="0" rIns="0" bIns="0" anchor="t">
-            <a:normAutofit fontScale="61911" lnSpcReduction="10000"/>
+            <a:normAutofit fontScale="54411" lnSpcReduction="20000"/>
           </a:bodyPr>
           <a:lstStyle/>
           <a:p>
@@ -6188,7 +6193,7 @@
         </p:spPr>
         <p:txBody>
           <a:bodyPr lIns="0" tIns="0" rIns="0" bIns="0" anchor="t">
-            <a:normAutofit fontScale="61911" lnSpcReduction="10000"/>
+            <a:normAutofit fontScale="54411" lnSpcReduction="20000"/>
           </a:bodyPr>
           <a:lstStyle/>
           <a:p>
@@ -6359,7 +6364,7 @@
         </p:spPr>
         <p:txBody>
           <a:bodyPr lIns="0" tIns="0" rIns="0" bIns="0" anchor="t">
-            <a:normAutofit fontScale="61911" lnSpcReduction="10000"/>
+            <a:normAutofit fontScale="54411" lnSpcReduction="20000"/>
           </a:bodyPr>
           <a:lstStyle/>
           <a:p>
@@ -7385,7 +7390,7 @@
         </p:spPr>
         <p:txBody>
           <a:bodyPr lIns="0" tIns="0" rIns="0" bIns="0" anchor="t">
-            <a:normAutofit fontScale="82197" lnSpcReduction="10000"/>
+            <a:normAutofit fontScale="89697" lnSpcReduction="20000"/>
           </a:bodyPr>
           <a:lstStyle/>
           <a:p>
@@ -7583,7 +7588,7 @@
         </p:spPr>
         <p:txBody>
           <a:bodyPr lIns="0" tIns="0" rIns="0" bIns="0" anchor="t">
-            <a:normAutofit fontScale="82197" lnSpcReduction="10000"/>
+            <a:normAutofit fontScale="89697" lnSpcReduction="20000"/>
           </a:bodyPr>
           <a:lstStyle/>
           <a:p>
@@ -12105,7 +12110,7 @@
         </p:spPr>
         <p:txBody>
           <a:bodyPr lIns="0" tIns="0" rIns="0" bIns="0" anchor="t">
-            <a:normAutofit fontScale="64734" lnSpcReduction="10000"/>
+            <a:normAutofit fontScale="64734" lnSpcReduction="20000"/>
           </a:bodyPr>
           <a:lstStyle/>
           <a:p>
@@ -13263,7 +13268,7 @@
         </p:spPr>
         <p:txBody>
           <a:bodyPr lIns="0" tIns="0" rIns="0" bIns="0" anchor="t">
-            <a:normAutofit fontScale="84656" lnSpcReduction="10000"/>
+            <a:normAutofit fontScale="92156" lnSpcReduction="10000"/>
           </a:bodyPr>
           <a:lstStyle/>
           <a:p>
@@ -13325,7 +13330,7 @@
         </p:spPr>
         <p:txBody>
           <a:bodyPr lIns="0" tIns="0" rIns="0" bIns="0" anchor="t">
-            <a:normAutofit fontScale="84656" lnSpcReduction="10000"/>
+            <a:normAutofit fontScale="92156" lnSpcReduction="10000"/>
           </a:bodyPr>
           <a:lstStyle/>
           <a:p>
@@ -13453,7 +13458,7 @@
         </p:spPr>
         <p:txBody>
           <a:bodyPr lIns="0" tIns="0" rIns="0" bIns="0" anchor="t">
-            <a:normAutofit fontScale="84656" lnSpcReduction="10000"/>
+            <a:normAutofit fontScale="92156" lnSpcReduction="10000"/>
           </a:bodyPr>
           <a:lstStyle/>
           <a:p>
@@ -13515,7 +13520,7 @@
         </p:spPr>
         <p:txBody>
           <a:bodyPr lIns="0" tIns="0" rIns="0" bIns="0" anchor="t">
-            <a:normAutofit fontScale="84656" lnSpcReduction="10000"/>
+            <a:normAutofit fontScale="92156" lnSpcReduction="10000"/>
           </a:bodyPr>
           <a:lstStyle/>
           <a:p>
@@ -13643,7 +13648,7 @@
         </p:spPr>
         <p:txBody>
           <a:bodyPr lIns="0" tIns="0" rIns="0" bIns="0" anchor="t">
-            <a:normAutofit fontScale="84656" lnSpcReduction="10000"/>
+            <a:normAutofit fontScale="92156" lnSpcReduction="10000"/>
           </a:bodyPr>
           <a:lstStyle/>
           <a:p>
@@ -13705,7 +13710,7 @@
         </p:spPr>
         <p:txBody>
           <a:bodyPr lIns="0" tIns="0" rIns="0" bIns="0" anchor="t">
-            <a:normAutofit fontScale="84656" lnSpcReduction="10000"/>
+            <a:normAutofit fontScale="92156" lnSpcReduction="10000"/>
           </a:bodyPr>
           <a:lstStyle/>
           <a:p>
@@ -13833,7 +13838,7 @@
         </p:spPr>
         <p:txBody>
           <a:bodyPr lIns="0" tIns="0" rIns="0" bIns="0" anchor="t">
-            <a:normAutofit fontScale="84656" lnSpcReduction="10000"/>
+            <a:normAutofit fontScale="92156" lnSpcReduction="10000"/>
           </a:bodyPr>
           <a:lstStyle/>
           <a:p>
@@ -13895,7 +13900,7 @@
         </p:spPr>
         <p:txBody>
           <a:bodyPr lIns="0" tIns="0" rIns="0" bIns="0" anchor="t">
-            <a:normAutofit fontScale="84656" lnSpcReduction="10000"/>
+            <a:normAutofit fontScale="92156" lnSpcReduction="10000"/>
           </a:bodyPr>
           <a:lstStyle/>
           <a:p>
@@ -21181,7 +21186,7 @@
         </p:spPr>
         <p:txBody>
           <a:bodyPr lIns="0" tIns="0" rIns="0" bIns="0" anchor="t">
-            <a:normAutofit fontScale="61873" lnSpcReduction="10000"/>
+            <a:normAutofit fontScale="61873" lnSpcReduction="20000"/>
           </a:bodyPr>
           <a:lstStyle/>
           <a:p>
@@ -33089,7 +33094,7 @@
                 <a:latin typeface="Consolas"/>
                 <a:cs typeface="Consolas"/>
               </a:rPr>
-              <a:t>install</a:t>
+              <a:t>--install</a:t>
             </a:r>
             <a:endParaRPr sz="3200" dirty="0">
               <a:solidFill>

</xml_diff>